<commit_message>
Update SIH deck from the college AI review
Adds a one-line value proposition, a decision flowchart with the real
limits, a competitor map, the kit data plan, per-maker kit profiles,
a quantified impact line and card-on-kit-pouch; slide 2 now shows the
real phone test result.

Co-Authored-By: Claude Opus 5.5 <noreply@anthropic.com>
</commit_message>
<xml_diff>
--- a/docs/SIH26231_FieldProof_HexTech.pptx
+++ b/docs/SIH26231_FieldProof_HexTech.pptx
@@ -4026,8 +4026,8 @@
         </p:nvSpPr>
         <p:spPr>
           <a:xfrm>
-            <a:off x="877824" y="1874519"/>
-            <a:ext cx="6858000" cy="411480"/>
+            <a:off x="2926080" y="1298448"/>
+            <a:ext cx="11704320" cy="457200"/>
           </a:xfrm>
           <a:prstGeom prst="rect">
             <a:avLst/>
@@ -4040,6 +4040,41 @@
           </a:bodyPr>
           <a:lstStyle/>
           <a:p>
+            <a:pPr algn="ctr"/>
+            <a:r>
+              <a:rPr sz="1550" b="1" i="1">
+                <a:solidFill>
+                  <a:srgbClr val="0F766E"/>
+                </a:solidFill>
+                <a:latin typeface="Calibri"/>
+              </a:rPr>
+              <a:t>FieldProof: any phone + a ₹10 colour card = an objective drug-test result, sealed as tamper-proof evidence.</a:t>
+            </a:r>
+          </a:p>
+        </p:txBody>
+      </p:sp>
+      <p:sp>
+        <p:nvSpPr>
+          <p:cNvPr id="21" name="TextBox 20"/>
+          <p:cNvSpPr txBox="1"/>
+          <p:nvPr/>
+        </p:nvSpPr>
+        <p:spPr>
+          <a:xfrm>
+            <a:off x="877824" y="1874519"/>
+            <a:ext cx="6858000" cy="411480"/>
+          </a:xfrm>
+          <a:prstGeom prst="rect">
+            <a:avLst/>
+          </a:prstGeom>
+          <a:noFill/>
+        </p:spPr>
+        <p:txBody>
+          <a:bodyPr wrap="square" anchor="t" lIns="45720" rIns="45720" tIns="18288" bIns="18288">
+            <a:spAutoFit/>
+          </a:bodyPr>
+          <a:lstStyle/>
+          <a:p>
             <a:pPr algn="l"/>
             <a:r>
               <a:rPr sz="2300" b="1" i="0">
@@ -4055,7 +4090,7 @@
       </p:sp>
       <p:sp>
         <p:nvSpPr>
-          <p:cNvPr id="21" name="TextBox 20"/>
+          <p:cNvPr id="22" name="TextBox 21"/>
           <p:cNvSpPr txBox="1"/>
           <p:nvPr/>
         </p:nvSpPr>
@@ -4114,7 +4149,7 @@
       </p:sp>
       <p:sp>
         <p:nvSpPr>
-          <p:cNvPr id="22" name="TextBox 21"/>
+          <p:cNvPr id="23" name="TextBox 22"/>
           <p:cNvSpPr txBox="1"/>
           <p:nvPr/>
         </p:nvSpPr>
@@ -4149,7 +4184,7 @@
       </p:sp>
       <p:sp>
         <p:nvSpPr>
-          <p:cNvPr id="23" name="TextBox 22"/>
+          <p:cNvPr id="24" name="TextBox 23"/>
           <p:cNvSpPr txBox="1"/>
           <p:nvPr/>
         </p:nvSpPr>
@@ -4280,7 +4315,7 @@
       </p:sp>
       <p:sp>
         <p:nvSpPr>
-          <p:cNvPr id="24" name="TextBox 23"/>
+          <p:cNvPr id="25" name="TextBox 24"/>
           <p:cNvSpPr txBox="1"/>
           <p:nvPr/>
         </p:nvSpPr>
@@ -4315,7 +4350,7 @@
       </p:sp>
       <p:sp>
         <p:nvSpPr>
-          <p:cNvPr id="25" name="Rounded Rectangle 24"/>
+          <p:cNvPr id="26" name="Rounded Rectangle 25"/>
           <p:cNvSpPr/>
           <p:nvPr/>
         </p:nvSpPr>
@@ -4384,7 +4419,7 @@
       </p:sp>
       <p:cxnSp>
         <p:nvCxnSpPr>
-          <p:cNvPr id="26" name="Connector 25"/>
+          <p:cNvPr id="27" name="Connector 26"/>
           <p:cNvCxnSpPr/>
           <p:nvPr/>
         </p:nvCxnSpPr>
@@ -4392,41 +4427,6 @@
           <a:xfrm>
             <a:off x="4023360" y="5367528"/>
             <a:ext cx="0" cy="210312"/>
-          </a:xfrm>
-          <a:prstGeom prst="line">
-            <a:avLst/>
-          </a:prstGeom>
-          <a:ln w="22225">
-            <a:solidFill>
-              <a:srgbClr val="B07C5B"/>
-            </a:solidFill>
-          </a:ln>
-        </p:spPr>
-        <p:style>
-          <a:lnRef idx="2">
-            <a:schemeClr val="accent1"/>
-          </a:lnRef>
-          <a:fillRef idx="0">
-            <a:schemeClr val="accent1"/>
-          </a:fillRef>
-          <a:effectRef idx="1">
-            <a:schemeClr val="accent1"/>
-          </a:effectRef>
-          <a:fontRef idx="minor">
-            <a:schemeClr val="tx1"/>
-          </a:fontRef>
-        </p:style>
-      </p:cxnSp>
-      <p:cxnSp>
-        <p:nvCxnSpPr>
-          <p:cNvPr id="27" name="Connector 26"/>
-          <p:cNvCxnSpPr/>
-          <p:nvPr/>
-        </p:nvCxnSpPr>
-        <p:spPr>
-          <a:xfrm>
-            <a:off x="1600200" y="5577840"/>
-            <a:ext cx="4846320" cy="0"/>
           </a:xfrm>
           <a:prstGeom prst="line">
             <a:avLst/>
@@ -4461,6 +4461,41 @@
         <p:spPr>
           <a:xfrm>
             <a:off x="1600200" y="5577840"/>
+            <a:ext cx="4846320" cy="0"/>
+          </a:xfrm>
+          <a:prstGeom prst="line">
+            <a:avLst/>
+          </a:prstGeom>
+          <a:ln w="22225">
+            <a:solidFill>
+              <a:srgbClr val="B07C5B"/>
+            </a:solidFill>
+          </a:ln>
+        </p:spPr>
+        <p:style>
+          <a:lnRef idx="2">
+            <a:schemeClr val="accent1"/>
+          </a:lnRef>
+          <a:fillRef idx="0">
+            <a:schemeClr val="accent1"/>
+          </a:fillRef>
+          <a:effectRef idx="1">
+            <a:schemeClr val="accent1"/>
+          </a:effectRef>
+          <a:fontRef idx="minor">
+            <a:schemeClr val="tx1"/>
+          </a:fontRef>
+        </p:style>
+      </p:cxnSp>
+      <p:cxnSp>
+        <p:nvCxnSpPr>
+          <p:cNvPr id="29" name="Connector 28"/>
+          <p:cNvCxnSpPr/>
+          <p:nvPr/>
+        </p:nvCxnSpPr>
+        <p:spPr>
+          <a:xfrm>
+            <a:off x="1600200" y="5577840"/>
             <a:ext cx="0" cy="228600"/>
           </a:xfrm>
           <a:prstGeom prst="line">
@@ -4490,7 +4525,7 @@
       </p:cxnSp>
       <p:sp>
         <p:nvSpPr>
-          <p:cNvPr id="29" name="Rounded Rectangle 28"/>
+          <p:cNvPr id="30" name="Rounded Rectangle 29"/>
           <p:cNvSpPr/>
           <p:nvPr/>
         </p:nvSpPr>
@@ -4547,7 +4582,7 @@
       </p:sp>
       <p:cxnSp>
         <p:nvCxnSpPr>
-          <p:cNvPr id="30" name="Connector 29"/>
+          <p:cNvPr id="31" name="Connector 30"/>
           <p:cNvCxnSpPr/>
           <p:nvPr/>
         </p:nvCxnSpPr>
@@ -4583,7 +4618,7 @@
       </p:cxnSp>
       <p:sp>
         <p:nvSpPr>
-          <p:cNvPr id="31" name="Rounded Rectangle 30"/>
+          <p:cNvPr id="32" name="Rounded Rectangle 31"/>
           <p:cNvSpPr/>
           <p:nvPr/>
         </p:nvSpPr>
@@ -4640,7 +4675,7 @@
       </p:sp>
       <p:cxnSp>
         <p:nvCxnSpPr>
-          <p:cNvPr id="32" name="Connector 31"/>
+          <p:cNvPr id="33" name="Connector 32"/>
           <p:cNvCxnSpPr/>
           <p:nvPr/>
         </p:nvCxnSpPr>
@@ -4676,7 +4711,7 @@
       </p:cxnSp>
       <p:sp>
         <p:nvSpPr>
-          <p:cNvPr id="33" name="Rounded Rectangle 32"/>
+          <p:cNvPr id="34" name="Rounded Rectangle 33"/>
           <p:cNvSpPr/>
           <p:nvPr/>
         </p:nvSpPr>
@@ -4733,7 +4768,7 @@
       </p:sp>
       <p:cxnSp>
         <p:nvCxnSpPr>
-          <p:cNvPr id="34" name="Connector 33"/>
+          <p:cNvPr id="35" name="Connector 34"/>
           <p:cNvCxnSpPr/>
           <p:nvPr/>
         </p:nvCxnSpPr>
@@ -4769,7 +4804,7 @@
       </p:cxnSp>
       <p:sp>
         <p:nvSpPr>
-          <p:cNvPr id="35" name="Rounded Rectangle 34"/>
+          <p:cNvPr id="36" name="Rounded Rectangle 35"/>
           <p:cNvSpPr/>
           <p:nvPr/>
         </p:nvSpPr>
@@ -4838,7 +4873,7 @@
       </p:sp>
       <p:cxnSp>
         <p:nvCxnSpPr>
-          <p:cNvPr id="36" name="Connector 35"/>
+          <p:cNvPr id="37" name="Connector 36"/>
           <p:cNvCxnSpPr/>
           <p:nvPr/>
         </p:nvCxnSpPr>
@@ -4874,7 +4909,7 @@
       </p:cxnSp>
       <p:sp>
         <p:nvSpPr>
-          <p:cNvPr id="37" name="Rounded Rectangle 36"/>
+          <p:cNvPr id="38" name="Rounded Rectangle 37"/>
           <p:cNvSpPr/>
           <p:nvPr/>
         </p:nvSpPr>
@@ -4943,7 +4978,7 @@
       </p:sp>
       <p:cxnSp>
         <p:nvCxnSpPr>
-          <p:cNvPr id="38" name="Connector 37"/>
+          <p:cNvPr id="39" name="Connector 38"/>
           <p:cNvCxnSpPr/>
           <p:nvPr/>
         </p:nvCxnSpPr>
@@ -4979,7 +5014,7 @@
       </p:cxnSp>
       <p:sp>
         <p:nvSpPr>
-          <p:cNvPr id="39" name="Rounded Rectangle 38"/>
+          <p:cNvPr id="40" name="Rounded Rectangle 39"/>
           <p:cNvSpPr/>
           <p:nvPr/>
         </p:nvSpPr>
@@ -5048,7 +5083,7 @@
       </p:sp>
       <p:cxnSp>
         <p:nvCxnSpPr>
-          <p:cNvPr id="40" name="Connector 39"/>
+          <p:cNvPr id="41" name="Connector 40"/>
           <p:cNvCxnSpPr/>
           <p:nvPr/>
         </p:nvCxnSpPr>
@@ -5084,7 +5119,7 @@
       </p:cxnSp>
       <p:sp>
         <p:nvSpPr>
-          <p:cNvPr id="41" name="Rounded Rectangle 40"/>
+          <p:cNvPr id="42" name="Rounded Rectangle 41"/>
           <p:cNvSpPr/>
           <p:nvPr/>
         </p:nvSpPr>
@@ -5153,7 +5188,7 @@
       </p:sp>
       <p:cxnSp>
         <p:nvCxnSpPr>
-          <p:cNvPr id="42" name="Connector 41"/>
+          <p:cNvPr id="43" name="Connector 42"/>
           <p:cNvCxnSpPr/>
           <p:nvPr/>
         </p:nvCxnSpPr>
@@ -5189,7 +5224,7 @@
       </p:cxnSp>
       <p:sp>
         <p:nvSpPr>
-          <p:cNvPr id="43" name="Rounded Rectangle 42"/>
+          <p:cNvPr id="44" name="Rounded Rectangle 43"/>
           <p:cNvSpPr/>
           <p:nvPr/>
         </p:nvSpPr>
@@ -5258,7 +5293,7 @@
       </p:sp>
       <p:cxnSp>
         <p:nvCxnSpPr>
-          <p:cNvPr id="44" name="Connector 43"/>
+          <p:cNvPr id="45" name="Connector 44"/>
           <p:cNvCxnSpPr/>
           <p:nvPr/>
         </p:nvCxnSpPr>
@@ -5294,7 +5329,7 @@
       </p:cxnSp>
       <p:sp>
         <p:nvSpPr>
-          <p:cNvPr id="45" name="Rounded Rectangle 44"/>
+          <p:cNvPr id="46" name="Rounded Rectangle 45"/>
           <p:cNvSpPr/>
           <p:nvPr/>
         </p:nvSpPr>
@@ -5363,7 +5398,7 @@
       </p:sp>
       <p:cxnSp>
         <p:nvCxnSpPr>
-          <p:cNvPr id="46" name="Connector 45"/>
+          <p:cNvPr id="47" name="Connector 46"/>
           <p:cNvCxnSpPr/>
           <p:nvPr/>
         </p:nvCxnSpPr>
@@ -5399,7 +5434,7 @@
       </p:cxnSp>
       <p:sp>
         <p:nvSpPr>
-          <p:cNvPr id="47" name="Rounded Rectangle 46"/>
+          <p:cNvPr id="48" name="Rounded Rectangle 47"/>
           <p:cNvSpPr/>
           <p:nvPr/>
         </p:nvSpPr>
@@ -5468,7 +5503,7 @@
       </p:sp>
       <p:cxnSp>
         <p:nvCxnSpPr>
-          <p:cNvPr id="48" name="Connector 47"/>
+          <p:cNvPr id="49" name="Connector 48"/>
           <p:cNvCxnSpPr/>
           <p:nvPr/>
         </p:nvCxnSpPr>
@@ -5504,7 +5539,7 @@
       </p:cxnSp>
       <p:sp>
         <p:nvSpPr>
-          <p:cNvPr id="49" name="Rounded Rectangle 48"/>
+          <p:cNvPr id="50" name="Rounded Rectangle 49"/>
           <p:cNvSpPr/>
           <p:nvPr/>
         </p:nvSpPr>
@@ -5573,7 +5608,7 @@
       </p:sp>
       <p:cxnSp>
         <p:nvCxnSpPr>
-          <p:cNvPr id="50" name="Connector 49"/>
+          <p:cNvPr id="51" name="Connector 50"/>
           <p:cNvCxnSpPr/>
           <p:nvPr/>
         </p:nvCxnSpPr>
@@ -5609,7 +5644,7 @@
       </p:cxnSp>
       <p:sp>
         <p:nvSpPr>
-          <p:cNvPr id="51" name="Rounded Rectangle 50"/>
+          <p:cNvPr id="52" name="Rounded Rectangle 51"/>
           <p:cNvSpPr/>
           <p:nvPr/>
         </p:nvSpPr>
@@ -5678,7 +5713,7 @@
       </p:sp>
       <p:cxnSp>
         <p:nvCxnSpPr>
-          <p:cNvPr id="52" name="Connector 51"/>
+          <p:cNvPr id="53" name="Connector 52"/>
           <p:cNvCxnSpPr/>
           <p:nvPr/>
         </p:nvCxnSpPr>
@@ -5686,42 +5721,6 @@
           <a:xfrm>
             <a:off x="1600200" y="8686800"/>
             <a:ext cx="0" cy="365760"/>
-          </a:xfrm>
-          <a:prstGeom prst="line">
-            <a:avLst/>
-          </a:prstGeom>
-          <a:ln w="22225">
-            <a:solidFill>
-              <a:srgbClr val="B07C5B"/>
-            </a:solidFill>
-            <a:prstDash val="dash"/>
-          </a:ln>
-        </p:spPr>
-        <p:style>
-          <a:lnRef idx="2">
-            <a:schemeClr val="accent1"/>
-          </a:lnRef>
-          <a:fillRef idx="0">
-            <a:schemeClr val="accent1"/>
-          </a:fillRef>
-          <a:effectRef idx="1">
-            <a:schemeClr val="accent1"/>
-          </a:effectRef>
-          <a:fontRef idx="minor">
-            <a:schemeClr val="tx1"/>
-          </a:fontRef>
-        </p:style>
-      </p:cxnSp>
-      <p:cxnSp>
-        <p:nvCxnSpPr>
-          <p:cNvPr id="53" name="Connector 52"/>
-          <p:cNvCxnSpPr/>
-          <p:nvPr/>
-        </p:nvCxnSpPr>
-        <p:spPr>
-          <a:xfrm>
-            <a:off x="1600200" y="9052560"/>
-            <a:ext cx="1216152" cy="0"/>
           </a:xfrm>
           <a:prstGeom prst="line">
             <a:avLst/>
@@ -5755,9 +5754,9 @@
           <p:nvPr/>
         </p:nvCxnSpPr>
         <p:spPr>
-          <a:xfrm flipV="1">
-            <a:off x="2816352" y="6858000"/>
-            <a:ext cx="0" cy="2194560"/>
+          <a:xfrm>
+            <a:off x="1600200" y="9052560"/>
+            <a:ext cx="1216152" cy="0"/>
           </a:xfrm>
           <a:prstGeom prst="line">
             <a:avLst/>
@@ -5791,6 +5790,42 @@
           <p:nvPr/>
         </p:nvCxnSpPr>
         <p:spPr>
+          <a:xfrm flipV="1">
+            <a:off x="2816352" y="6858000"/>
+            <a:ext cx="0" cy="2194560"/>
+          </a:xfrm>
+          <a:prstGeom prst="line">
+            <a:avLst/>
+          </a:prstGeom>
+          <a:ln w="22225">
+            <a:solidFill>
+              <a:srgbClr val="B07C5B"/>
+            </a:solidFill>
+            <a:prstDash val="dash"/>
+          </a:ln>
+        </p:spPr>
+        <p:style>
+          <a:lnRef idx="2">
+            <a:schemeClr val="accent1"/>
+          </a:lnRef>
+          <a:fillRef idx="0">
+            <a:schemeClr val="accent1"/>
+          </a:fillRef>
+          <a:effectRef idx="1">
+            <a:schemeClr val="accent1"/>
+          </a:effectRef>
+          <a:fontRef idx="minor">
+            <a:schemeClr val="tx1"/>
+          </a:fontRef>
+        </p:style>
+      </p:cxnSp>
+      <p:cxnSp>
+        <p:nvCxnSpPr>
+          <p:cNvPr id="56" name="Connector 55"/>
+          <p:cNvCxnSpPr/>
+          <p:nvPr/>
+        </p:nvCxnSpPr>
+        <p:spPr>
           <a:xfrm>
             <a:off x="2816352" y="6858000"/>
             <a:ext cx="155448" cy="0"/>
@@ -5823,7 +5858,7 @@
       </p:cxnSp>
       <p:sp>
         <p:nvSpPr>
-          <p:cNvPr id="56" name="Rounded Rectangle 55"/>
+          <p:cNvPr id="57" name="Rounded Rectangle 56"/>
           <p:cNvSpPr/>
           <p:nvPr/>
         </p:nvSpPr>
@@ -5881,7 +5916,7 @@
       </p:sp>
       <p:sp>
         <p:nvSpPr>
-          <p:cNvPr id="57" name="TextBox 56"/>
+          <p:cNvPr id="58" name="TextBox 57"/>
           <p:cNvSpPr txBox="1"/>
           <p:nvPr/>
         </p:nvSpPr>
@@ -5916,7 +5951,7 @@
       </p:sp>
       <p:sp>
         <p:nvSpPr>
-          <p:cNvPr id="58" name="Rounded Rectangle 57"/>
+          <p:cNvPr id="59" name="Rounded Rectangle 58"/>
           <p:cNvSpPr/>
           <p:nvPr/>
         </p:nvSpPr>
@@ -5985,7 +6020,7 @@
       </p:sp>
       <p:sp>
         <p:nvSpPr>
-          <p:cNvPr id="59" name="Rounded Rectangle 58"/>
+          <p:cNvPr id="60" name="Rounded Rectangle 59"/>
           <p:cNvSpPr/>
           <p:nvPr/>
         </p:nvSpPr>
@@ -6054,7 +6089,7 @@
       </p:sp>
       <p:sp>
         <p:nvSpPr>
-          <p:cNvPr id="60" name="Rounded Rectangle 59"/>
+          <p:cNvPr id="61" name="Rounded Rectangle 60"/>
           <p:cNvSpPr/>
           <p:nvPr/>
         </p:nvSpPr>
@@ -6123,7 +6158,7 @@
       </p:sp>
       <p:sp>
         <p:nvSpPr>
-          <p:cNvPr id="61" name="Diamond 60"/>
+          <p:cNvPr id="62" name="Diamond 61"/>
           <p:cNvSpPr/>
           <p:nvPr/>
         </p:nvSpPr>
@@ -6190,49 +6225,13 @@
       </p:sp>
       <p:cxnSp>
         <p:nvCxnSpPr>
-          <p:cNvPr id="62" name="Connector 61"/>
-          <p:cNvCxnSpPr/>
-          <p:nvPr/>
-        </p:nvCxnSpPr>
-        <p:spPr>
-          <a:xfrm>
-            <a:off x="9966960" y="5769864"/>
-            <a:ext cx="228600" cy="0"/>
-          </a:xfrm>
-          <a:prstGeom prst="line">
-            <a:avLst/>
-          </a:prstGeom>
-          <a:ln w="22225">
-            <a:solidFill>
-              <a:srgbClr val="7F7F7F"/>
-            </a:solidFill>
-            <a:tailEnd type="triangle" w="med" h="med"/>
-          </a:ln>
-        </p:spPr>
-        <p:style>
-          <a:lnRef idx="2">
-            <a:schemeClr val="accent1"/>
-          </a:lnRef>
-          <a:fillRef idx="0">
-            <a:schemeClr val="accent1"/>
-          </a:fillRef>
-          <a:effectRef idx="1">
-            <a:schemeClr val="accent1"/>
-          </a:effectRef>
-          <a:fontRef idx="minor">
-            <a:schemeClr val="tx1"/>
-          </a:fontRef>
-        </p:style>
-      </p:cxnSp>
-      <p:cxnSp>
-        <p:nvCxnSpPr>
           <p:cNvPr id="63" name="Connector 62"/>
           <p:cNvCxnSpPr/>
           <p:nvPr/>
         </p:nvCxnSpPr>
         <p:spPr>
           <a:xfrm>
-            <a:off x="11932920" y="5769864"/>
+            <a:off x="9966960" y="5769864"/>
             <a:ext cx="228600" cy="0"/>
           </a:xfrm>
           <a:prstGeom prst="line">
@@ -6268,7 +6267,7 @@
         </p:nvCxnSpPr>
         <p:spPr>
           <a:xfrm>
-            <a:off x="13898880" y="5769864"/>
+            <a:off x="11932920" y="5769864"/>
             <a:ext cx="228600" cy="0"/>
           </a:xfrm>
           <a:prstGeom prst="line">
@@ -6296,9 +6295,45 @@
           </a:fontRef>
         </p:style>
       </p:cxnSp>
-      <p:sp>
-        <p:nvSpPr>
-          <p:cNvPr id="65" name="Rounded Rectangle 64"/>
+      <p:cxnSp>
+        <p:nvCxnSpPr>
+          <p:cNvPr id="65" name="Connector 64"/>
+          <p:cNvCxnSpPr/>
+          <p:nvPr/>
+        </p:nvCxnSpPr>
+        <p:spPr>
+          <a:xfrm>
+            <a:off x="13898880" y="5769864"/>
+            <a:ext cx="228600" cy="0"/>
+          </a:xfrm>
+          <a:prstGeom prst="line">
+            <a:avLst/>
+          </a:prstGeom>
+          <a:ln w="22225">
+            <a:solidFill>
+              <a:srgbClr val="7F7F7F"/>
+            </a:solidFill>
+            <a:tailEnd type="triangle" w="med" h="med"/>
+          </a:ln>
+        </p:spPr>
+        <p:style>
+          <a:lnRef idx="2">
+            <a:schemeClr val="accent1"/>
+          </a:lnRef>
+          <a:fillRef idx="0">
+            <a:schemeClr val="accent1"/>
+          </a:fillRef>
+          <a:effectRef idx="1">
+            <a:schemeClr val="accent1"/>
+          </a:effectRef>
+          <a:fontRef idx="minor">
+            <a:schemeClr val="tx1"/>
+          </a:fontRef>
+        </p:style>
+      </p:cxnSp>
+      <p:sp>
+        <p:nvSpPr>
+          <p:cNvPr id="66" name="Rounded Rectangle 65"/>
           <p:cNvSpPr/>
           <p:nvPr/>
         </p:nvSpPr>
@@ -6356,7 +6391,7 @@
       </p:sp>
       <p:sp>
         <p:nvSpPr>
-          <p:cNvPr id="66" name="Rounded Rectangle 65"/>
+          <p:cNvPr id="67" name="Rounded Rectangle 66"/>
           <p:cNvSpPr/>
           <p:nvPr/>
         </p:nvSpPr>
@@ -6414,7 +6449,7 @@
       </p:sp>
       <p:cxnSp>
         <p:nvCxnSpPr>
-          <p:cNvPr id="67" name="Connector 66"/>
+          <p:cNvPr id="68" name="Connector 67"/>
           <p:cNvCxnSpPr/>
           <p:nvPr/>
         </p:nvCxnSpPr>
@@ -6422,41 +6457,6 @@
           <a:xfrm>
             <a:off x="14973300" y="6327648"/>
             <a:ext cx="0" cy="256032"/>
-          </a:xfrm>
-          <a:prstGeom prst="line">
-            <a:avLst/>
-          </a:prstGeom>
-          <a:ln w="22225">
-            <a:solidFill>
-              <a:srgbClr val="7F7F7F"/>
-            </a:solidFill>
-          </a:ln>
-        </p:spPr>
-        <p:style>
-          <a:lnRef idx="2">
-            <a:schemeClr val="accent1"/>
-          </a:lnRef>
-          <a:fillRef idx="0">
-            <a:schemeClr val="accent1"/>
-          </a:fillRef>
-          <a:effectRef idx="1">
-            <a:schemeClr val="accent1"/>
-          </a:effectRef>
-          <a:fontRef idx="minor">
-            <a:schemeClr val="tx1"/>
-          </a:fontRef>
-        </p:style>
-      </p:cxnSp>
-      <p:cxnSp>
-        <p:nvCxnSpPr>
-          <p:cNvPr id="68" name="Connector 67"/>
-          <p:cNvCxnSpPr/>
-          <p:nvPr/>
-        </p:nvCxnSpPr>
-        <p:spPr>
-          <a:xfrm>
-            <a:off x="13670280" y="6583680"/>
-            <a:ext cx="3337560" cy="0"/>
           </a:xfrm>
           <a:prstGeom prst="line">
             <a:avLst/>
@@ -6491,6 +6491,41 @@
         <p:spPr>
           <a:xfrm>
             <a:off x="13670280" y="6583680"/>
+            <a:ext cx="3337560" cy="0"/>
+          </a:xfrm>
+          <a:prstGeom prst="line">
+            <a:avLst/>
+          </a:prstGeom>
+          <a:ln w="22225">
+            <a:solidFill>
+              <a:srgbClr val="7F7F7F"/>
+            </a:solidFill>
+          </a:ln>
+        </p:spPr>
+        <p:style>
+          <a:lnRef idx="2">
+            <a:schemeClr val="accent1"/>
+          </a:lnRef>
+          <a:fillRef idx="0">
+            <a:schemeClr val="accent1"/>
+          </a:fillRef>
+          <a:effectRef idx="1">
+            <a:schemeClr val="accent1"/>
+          </a:effectRef>
+          <a:fontRef idx="minor">
+            <a:schemeClr val="tx1"/>
+          </a:fontRef>
+        </p:style>
+      </p:cxnSp>
+      <p:cxnSp>
+        <p:nvCxnSpPr>
+          <p:cNvPr id="70" name="Connector 69"/>
+          <p:cNvCxnSpPr/>
+          <p:nvPr/>
+        </p:nvCxnSpPr>
+        <p:spPr>
+          <a:xfrm>
+            <a:off x="13670280" y="6583680"/>
             <a:ext cx="0" cy="228600"/>
           </a:xfrm>
           <a:prstGeom prst="line">
@@ -6520,7 +6555,7 @@
       </p:cxnSp>
       <p:sp>
         <p:nvSpPr>
-          <p:cNvPr id="70" name="Oval 69"/>
+          <p:cNvPr id="71" name="Oval 70"/>
           <p:cNvSpPr/>
           <p:nvPr/>
         </p:nvSpPr>
@@ -6575,7 +6610,7 @@
       </p:sp>
       <p:cxnSp>
         <p:nvCxnSpPr>
-          <p:cNvPr id="71" name="Connector 70"/>
+          <p:cNvPr id="72" name="Connector 71"/>
           <p:cNvCxnSpPr/>
           <p:nvPr/>
         </p:nvCxnSpPr>
@@ -6611,7 +6646,7 @@
       </p:cxnSp>
       <p:sp>
         <p:nvSpPr>
-          <p:cNvPr id="72" name="Oval 71"/>
+          <p:cNvPr id="73" name="Oval 72"/>
           <p:cNvSpPr/>
           <p:nvPr/>
         </p:nvSpPr>
@@ -6666,7 +6701,7 @@
       </p:sp>
       <p:cxnSp>
         <p:nvCxnSpPr>
-          <p:cNvPr id="73" name="Connector 72"/>
+          <p:cNvPr id="74" name="Connector 73"/>
           <p:cNvCxnSpPr/>
           <p:nvPr/>
         </p:nvCxnSpPr>
@@ -6702,7 +6737,7 @@
       </p:cxnSp>
       <p:sp>
         <p:nvSpPr>
-          <p:cNvPr id="74" name="Oval 73"/>
+          <p:cNvPr id="75" name="Oval 74"/>
           <p:cNvSpPr/>
           <p:nvPr/>
         </p:nvSpPr>
@@ -6769,7 +6804,7 @@
       </p:sp>
       <p:sp>
         <p:nvSpPr>
-          <p:cNvPr id="75" name="Rounded Rectangle 74"/>
+          <p:cNvPr id="76" name="Rounded Rectangle 75"/>
           <p:cNvSpPr/>
           <p:nvPr/>
         </p:nvSpPr>
@@ -6838,7 +6873,7 @@
       </p:sp>
       <p:sp>
         <p:nvSpPr>
-          <p:cNvPr id="76" name="Rounded Rectangle 75"/>
+          <p:cNvPr id="77" name="Rounded Rectangle 76"/>
           <p:cNvSpPr/>
           <p:nvPr/>
         </p:nvSpPr>
@@ -6907,49 +6942,13 @@
       </p:sp>
       <p:cxnSp>
         <p:nvCxnSpPr>
-          <p:cNvPr id="77" name="Connector 76"/>
-          <p:cNvCxnSpPr/>
-          <p:nvPr/>
-        </p:nvCxnSpPr>
-        <p:spPr>
-          <a:xfrm>
-            <a:off x="13670280" y="7315200"/>
-            <a:ext cx="0" cy="411479"/>
-          </a:xfrm>
-          <a:prstGeom prst="line">
-            <a:avLst/>
-          </a:prstGeom>
-          <a:ln w="22225">
-            <a:solidFill>
-              <a:srgbClr val="7F7F7F"/>
-            </a:solidFill>
-            <a:tailEnd type="triangle" w="med" h="med"/>
-          </a:ln>
-        </p:spPr>
-        <p:style>
-          <a:lnRef idx="2">
-            <a:schemeClr val="accent1"/>
-          </a:lnRef>
-          <a:fillRef idx="0">
-            <a:schemeClr val="accent1"/>
-          </a:fillRef>
-          <a:effectRef idx="1">
-            <a:schemeClr val="accent1"/>
-          </a:effectRef>
-          <a:fontRef idx="minor">
-            <a:schemeClr val="tx1"/>
-          </a:fontRef>
-        </p:style>
-      </p:cxnSp>
-      <p:cxnSp>
-        <p:nvCxnSpPr>
           <p:cNvPr id="78" name="Connector 77"/>
           <p:cNvCxnSpPr/>
           <p:nvPr/>
         </p:nvCxnSpPr>
         <p:spPr>
           <a:xfrm>
-            <a:off x="15361920" y="7315200"/>
+            <a:off x="13670280" y="7315200"/>
             <a:ext cx="0" cy="411479"/>
           </a:xfrm>
           <a:prstGeom prst="line">
@@ -6985,7 +6984,7 @@
         </p:nvCxnSpPr>
         <p:spPr>
           <a:xfrm>
-            <a:off x="17007840" y="7315200"/>
+            <a:off x="15361920" y="7315200"/>
             <a:ext cx="0" cy="411479"/>
           </a:xfrm>
           <a:prstGeom prst="line">
@@ -7013,9 +7012,45 @@
           </a:fontRef>
         </p:style>
       </p:cxnSp>
-      <p:sp>
-        <p:nvSpPr>
-          <p:cNvPr id="80" name="Rounded Rectangle 79"/>
+      <p:cxnSp>
+        <p:nvCxnSpPr>
+          <p:cNvPr id="80" name="Connector 79"/>
+          <p:cNvCxnSpPr/>
+          <p:nvPr/>
+        </p:nvCxnSpPr>
+        <p:spPr>
+          <a:xfrm>
+            <a:off x="17007840" y="7315200"/>
+            <a:ext cx="0" cy="411479"/>
+          </a:xfrm>
+          <a:prstGeom prst="line">
+            <a:avLst/>
+          </a:prstGeom>
+          <a:ln w="22225">
+            <a:solidFill>
+              <a:srgbClr val="7F7F7F"/>
+            </a:solidFill>
+            <a:tailEnd type="triangle" w="med" h="med"/>
+          </a:ln>
+        </p:spPr>
+        <p:style>
+          <a:lnRef idx="2">
+            <a:schemeClr val="accent1"/>
+          </a:lnRef>
+          <a:fillRef idx="0">
+            <a:schemeClr val="accent1"/>
+          </a:fillRef>
+          <a:effectRef idx="1">
+            <a:schemeClr val="accent1"/>
+          </a:effectRef>
+          <a:fontRef idx="minor">
+            <a:schemeClr val="tx1"/>
+          </a:fontRef>
+        </p:style>
+      </p:cxnSp>
+      <p:sp>
+        <p:nvSpPr>
+          <p:cNvPr id="81" name="Rounded Rectangle 80"/>
           <p:cNvSpPr/>
           <p:nvPr/>
         </p:nvSpPr>
@@ -7072,7 +7107,7 @@
       </p:sp>
       <p:cxnSp>
         <p:nvCxnSpPr>
-          <p:cNvPr id="81" name="Connector 80"/>
+          <p:cNvPr id="82" name="Connector 81"/>
           <p:cNvCxnSpPr/>
           <p:nvPr/>
         </p:nvCxnSpPr>
@@ -7089,41 +7124,6 @@
               <a:srgbClr val="7F7F7F"/>
             </a:solidFill>
             <a:tailEnd type="triangle" w="med" h="med"/>
-          </a:ln>
-        </p:spPr>
-        <p:style>
-          <a:lnRef idx="2">
-            <a:schemeClr val="accent1"/>
-          </a:lnRef>
-          <a:fillRef idx="0">
-            <a:schemeClr val="accent1"/>
-          </a:fillRef>
-          <a:effectRef idx="1">
-            <a:schemeClr val="accent1"/>
-          </a:effectRef>
-          <a:fontRef idx="minor">
-            <a:schemeClr val="tx1"/>
-          </a:fontRef>
-        </p:style>
-      </p:cxnSp>
-      <p:cxnSp>
-        <p:nvCxnSpPr>
-          <p:cNvPr id="82" name="Connector 81"/>
-          <p:cNvCxnSpPr/>
-          <p:nvPr/>
-        </p:nvCxnSpPr>
-        <p:spPr>
-          <a:xfrm>
-            <a:off x="17007840" y="8366760"/>
-            <a:ext cx="0" cy="594360"/>
-          </a:xfrm>
-          <a:prstGeom prst="line">
-            <a:avLst/>
-          </a:prstGeom>
-          <a:ln w="22225">
-            <a:solidFill>
-              <a:srgbClr val="7F7F7F"/>
-            </a:solidFill>
           </a:ln>
         </p:spPr>
         <p:style>
@@ -7148,6 +7148,41 @@
           <p:nvPr/>
         </p:nvCxnSpPr>
         <p:spPr>
+          <a:xfrm>
+            <a:off x="17007840" y="8366760"/>
+            <a:ext cx="0" cy="594360"/>
+          </a:xfrm>
+          <a:prstGeom prst="line">
+            <a:avLst/>
+          </a:prstGeom>
+          <a:ln w="22225">
+            <a:solidFill>
+              <a:srgbClr val="7F7F7F"/>
+            </a:solidFill>
+          </a:ln>
+        </p:spPr>
+        <p:style>
+          <a:lnRef idx="2">
+            <a:schemeClr val="accent1"/>
+          </a:lnRef>
+          <a:fillRef idx="0">
+            <a:schemeClr val="accent1"/>
+          </a:fillRef>
+          <a:effectRef idx="1">
+            <a:schemeClr val="accent1"/>
+          </a:effectRef>
+          <a:fontRef idx="minor">
+            <a:schemeClr val="tx1"/>
+          </a:fontRef>
+        </p:style>
+      </p:cxnSp>
+      <p:cxnSp>
+        <p:nvCxnSpPr>
+          <p:cNvPr id="84" name="Connector 83"/>
+          <p:cNvCxnSpPr/>
+          <p:nvPr/>
+        </p:nvCxnSpPr>
+        <p:spPr>
           <a:xfrm flipH="1">
             <a:off x="16139159" y="8961120"/>
             <a:ext cx="868681" cy="0"/>
@@ -7179,7 +7214,7 @@
       </p:cxnSp>
       <p:sp>
         <p:nvSpPr>
-          <p:cNvPr id="84" name="Rounded Rectangle 83"/>
+          <p:cNvPr id="85" name="Rounded Rectangle 84"/>
           <p:cNvSpPr/>
           <p:nvPr/>
         </p:nvSpPr>
@@ -7236,7 +7271,7 @@
       </p:sp>
       <p:sp>
         <p:nvSpPr>
-          <p:cNvPr id="85" name="TextBox 84"/>
+          <p:cNvPr id="86" name="TextBox 85"/>
           <p:cNvSpPr txBox="1"/>
           <p:nvPr/>
         </p:nvSpPr>
@@ -7264,14 +7299,14 @@
                 </a:solidFill>
                 <a:latin typeface="Calibri"/>
               </a:rPr>
-              <a:t>RESULT SCREEN (what the officer sees)</a:t>
-            </a:r>
-          </a:p>
-        </p:txBody>
-      </p:sp>
-      <p:sp>
-        <p:nvSpPr>
-          <p:cNvPr id="86" name="Rounded Rectangle 85"/>
+              <a:t>REAL RESULT from our phone test (28 Sep)</a:t>
+            </a:r>
+          </a:p>
+        </p:txBody>
+      </p:sp>
+      <p:sp>
+        <p:nvSpPr>
+          <p:cNvPr id="87" name="Rounded Rectangle 86"/>
           <p:cNvSpPr/>
           <p:nvPr/>
         </p:nvSpPr>
@@ -7321,14 +7356,14 @@
                 </a:solidFill>
                 <a:latin typeface="Calibri"/>
               </a:rPr>
-              <a:t>POSITIVE · opium-type drug · 91% sure</a:t>
-            </a:r>
-          </a:p>
-        </p:txBody>
-      </p:sp>
-      <p:sp>
-        <p:nvSpPr>
-          <p:cNvPr id="87" name="TextBox 86"/>
+              <a:t>POSITIVE · opium-type drug · 75% sure</a:t>
+            </a:r>
+          </a:p>
+        </p:txBody>
+      </p:sp>
+      <p:sp>
+        <p:nvSpPr>
+          <p:cNvPr id="88" name="TextBox 87"/>
           <p:cNvSpPr txBox="1"/>
           <p:nvPr/>
         </p:nvSpPr>
@@ -7356,14 +7391,14 @@
                 </a:solidFill>
                 <a:latin typeface="Calibri"/>
               </a:rPr>
-              <a:t>Colour difference = 4.2 (small number = close match)</a:t>
-            </a:r>
-          </a:p>
-        </p:txBody>
-      </p:sp>
-      <p:sp>
-        <p:nvSpPr>
-          <p:cNvPr id="88" name="Rounded Rectangle 87"/>
+              <a:t>Colour difference = 6.8 (small number = close match)</a:t>
+            </a:r>
+          </a:p>
+        </p:txBody>
+      </p:sp>
+      <p:sp>
+        <p:nvSpPr>
+          <p:cNvPr id="89" name="Rounded Rectangle 88"/>
           <p:cNvSpPr/>
           <p:nvPr/>
         </p:nvSpPr>
@@ -7409,7 +7444,7 @@
       </p:sp>
       <p:sp>
         <p:nvSpPr>
-          <p:cNvPr id="89" name="TextBox 88"/>
+          <p:cNvPr id="90" name="TextBox 89"/>
           <p:cNvSpPr txBox="1"/>
           <p:nvPr/>
         </p:nvSpPr>
@@ -7456,7 +7491,7 @@
       </p:sp>
       <p:sp>
         <p:nvSpPr>
-          <p:cNvPr id="90" name="Rounded Rectangle 89"/>
+          <p:cNvPr id="91" name="Rounded Rectangle 90"/>
           <p:cNvSpPr/>
           <p:nvPr/>
         </p:nvSpPr>
@@ -7502,7 +7537,7 @@
       </p:sp>
       <p:sp>
         <p:nvSpPr>
-          <p:cNvPr id="91" name="TextBox 90"/>
+          <p:cNvPr id="92" name="TextBox 91"/>
           <p:cNvSpPr txBox="1"/>
           <p:nvPr/>
         </p:nvSpPr>
@@ -7549,7 +7584,7 @@
       </p:sp>
       <p:sp>
         <p:nvSpPr>
-          <p:cNvPr id="92" name="Rounded Rectangle 91"/>
+          <p:cNvPr id="93" name="Rounded Rectangle 92"/>
           <p:cNvSpPr/>
           <p:nvPr/>
         </p:nvSpPr>
@@ -7595,7 +7630,7 @@
       </p:sp>
       <p:sp>
         <p:nvSpPr>
-          <p:cNvPr id="93" name="TextBox 92"/>
+          <p:cNvPr id="94" name="TextBox 93"/>
           <p:cNvSpPr txBox="1"/>
           <p:nvPr/>
         </p:nvSpPr>
@@ -7642,7 +7677,7 @@
       </p:sp>
       <p:sp>
         <p:nvSpPr>
-          <p:cNvPr id="94" name="TextBox 93"/>
+          <p:cNvPr id="95" name="TextBox 94"/>
           <p:cNvSpPr txBox="1"/>
           <p:nvPr/>
         </p:nvSpPr>
@@ -9210,8 +9245,8 @@
         </p:nvSpPr>
         <p:spPr>
           <a:xfrm>
-            <a:off x="12024360" y="2148840"/>
-            <a:ext cx="5394960" cy="411480"/>
+            <a:off x="11978640" y="2103120"/>
+            <a:ext cx="5486400" cy="411480"/>
           </a:xfrm>
           <a:prstGeom prst="rect">
             <a:avLst/>
@@ -9226,205 +9261,821 @@
           <a:p>
             <a:pPr algn="l"/>
             <a:r>
-              <a:rPr sz="2100" b="1" i="0">
+              <a:rPr sz="1800" b="1" i="0">
                 <a:solidFill>
                   <a:srgbClr val="1F3864"/>
                 </a:solidFill>
                 <a:latin typeface="Calibri"/>
               </a:rPr>
-              <a:t>How the App Decides</a:t>
-            </a:r>
-          </a:p>
-        </p:txBody>
-      </p:sp>
-      <p:sp>
-        <p:nvSpPr>
-          <p:cNvPr id="50" name="TextBox 49"/>
-          <p:cNvSpPr txBox="1"/>
-          <p:nvPr/>
-        </p:nvSpPr>
-        <p:spPr>
-          <a:xfrm>
-            <a:off x="12024360" y="2606040"/>
-            <a:ext cx="5486400" cy="2651760"/>
-          </a:xfrm>
-          <a:prstGeom prst="rect">
+              <a:t>How the App Decides (never guesses)</a:t>
+            </a:r>
+          </a:p>
+        </p:txBody>
+      </p:sp>
+      <p:sp>
+        <p:nvSpPr>
+          <p:cNvPr id="50" name="Rounded Rectangle 49"/>
+          <p:cNvSpPr/>
+          <p:nvPr/>
+        </p:nvSpPr>
+        <p:spPr>
+          <a:xfrm>
+            <a:off x="12024360" y="2560320"/>
+            <a:ext cx="3794760" cy="402336"/>
+          </a:xfrm>
+          <a:prstGeom prst="roundRect">
+            <a:avLst>
+              <a:gd name="adj" fmla="val 12000"/>
+            </a:avLst>
+          </a:prstGeom>
+          <a:solidFill>
+            <a:srgbClr val="FFFFFF"/>
+          </a:solidFill>
+          <a:ln w="15875">
+            <a:solidFill>
+              <a:srgbClr val="2F5597"/>
+            </a:solidFill>
+          </a:ln>
+          <a:effectLst/>
+        </p:spPr>
+        <p:style>
+          <a:lnRef idx="1">
+            <a:schemeClr val="accent1"/>
+          </a:lnRef>
+          <a:fillRef idx="3">
+            <a:schemeClr val="accent1"/>
+          </a:fillRef>
+          <a:effectRef idx="2">
+            <a:schemeClr val="accent1"/>
+          </a:effectRef>
+          <a:fontRef idx="minor">
+            <a:schemeClr val="lt1"/>
+          </a:fontRef>
+        </p:style>
+        <p:txBody>
+          <a:bodyPr rtlCol="0" anchor="ctr" wrap="square" lIns="45720" rIns="45720" tIns="18288" bIns="18288"/>
+          <a:lstStyle/>
+          <a:p>
+            <a:pPr algn="ctr"/>
+            <a:r>
+              <a:rPr sz="1150" b="1">
+                <a:solidFill>
+                  <a:srgbClr val="1A1A1A"/>
+                </a:solidFill>
+                <a:latin typeface="Calibri"/>
+              </a:rPr>
+              <a:t>1. All 4 card corners found?</a:t>
+            </a:r>
+          </a:p>
+        </p:txBody>
+      </p:sp>
+      <p:cxnSp>
+        <p:nvCxnSpPr>
+          <p:cNvPr id="51" name="Connector 50"/>
+          <p:cNvCxnSpPr/>
+          <p:nvPr/>
+        </p:nvCxnSpPr>
+        <p:spPr>
+          <a:xfrm>
+            <a:off x="15819120" y="2761488"/>
+            <a:ext cx="228600" cy="0"/>
+          </a:xfrm>
+          <a:prstGeom prst="line">
             <a:avLst/>
           </a:prstGeom>
-          <a:noFill/>
-        </p:spPr>
-        <p:txBody>
-          <a:bodyPr wrap="square" lIns="45720" rIns="45720">
-            <a:spAutoFit/>
-          </a:bodyPr>
+          <a:ln w="22225">
+            <a:solidFill>
+              <a:srgbClr val="7030A0"/>
+            </a:solidFill>
+            <a:tailEnd type="triangle" w="med" h="med"/>
+          </a:ln>
+        </p:spPr>
+        <p:style>
+          <a:lnRef idx="2">
+            <a:schemeClr val="accent1"/>
+          </a:lnRef>
+          <a:fillRef idx="0">
+            <a:schemeClr val="accent1"/>
+          </a:fillRef>
+          <a:effectRef idx="1">
+            <a:schemeClr val="accent1"/>
+          </a:effectRef>
+          <a:fontRef idx="minor">
+            <a:schemeClr val="tx1"/>
+          </a:fontRef>
+        </p:style>
+      </p:cxnSp>
+      <p:sp>
+        <p:nvSpPr>
+          <p:cNvPr id="52" name="Rounded Rectangle 51"/>
+          <p:cNvSpPr/>
+          <p:nvPr/>
+        </p:nvSpPr>
+        <p:spPr>
+          <a:xfrm>
+            <a:off x="16047720" y="2596896"/>
+            <a:ext cx="1417320" cy="329184"/>
+          </a:xfrm>
+          <a:prstGeom prst="roundRect">
+            <a:avLst>
+              <a:gd name="adj" fmla="val 12000"/>
+            </a:avLst>
+          </a:prstGeom>
+          <a:solidFill>
+            <a:srgbClr val="E6C8F5"/>
+          </a:solidFill>
+          <a:ln w="15875">
+            <a:solidFill>
+              <a:srgbClr val="7030A0"/>
+            </a:solidFill>
+          </a:ln>
+          <a:effectLst/>
+        </p:spPr>
+        <p:style>
+          <a:lnRef idx="1">
+            <a:schemeClr val="accent1"/>
+          </a:lnRef>
+          <a:fillRef idx="3">
+            <a:schemeClr val="accent1"/>
+          </a:fillRef>
+          <a:effectRef idx="2">
+            <a:schemeClr val="accent1"/>
+          </a:effectRef>
+          <a:fontRef idx="minor">
+            <a:schemeClr val="lt1"/>
+          </a:fontRef>
+        </p:style>
+        <p:txBody>
+          <a:bodyPr rtlCol="0" anchor="ctr" wrap="square" lIns="45720" rIns="45720" tIns="18288" bIns="18288"/>
           <a:lstStyle/>
           <a:p>
-            <a:pPr marL="292608" indent="-256032">
-              <a:spcAft>
-                <a:spcPts val="700"/>
-              </a:spcAft>
-              <a:buFont typeface="Arial"/>
-              <a:buChar char="•"/>
-            </a:pPr>
-            <a:r>
-              <a:rPr b="1" sz="1600">
+            <a:pPr algn="ctr"/>
+            <a:r>
+              <a:rPr sz="950" b="1">
                 <a:solidFill>
                   <a:srgbClr val="1A1A1A"/>
                 </a:solidFill>
                 <a:latin typeface="Calibri"/>
               </a:rPr>
-              <a:t>POSITIVE / NEGATIVE: </a:t>
-            </a:r>
-            <a:r>
-              <a:rPr sz="1600">
+              <a:t>No → NOT SURE</a:t>
+            </a:r>
+          </a:p>
+        </p:txBody>
+      </p:sp>
+      <p:cxnSp>
+        <p:nvCxnSpPr>
+          <p:cNvPr id="53" name="Connector 52"/>
+          <p:cNvCxnSpPr/>
+          <p:nvPr/>
+        </p:nvCxnSpPr>
+        <p:spPr>
+          <a:xfrm>
+            <a:off x="13917168" y="2962656"/>
+            <a:ext cx="0" cy="146304"/>
+          </a:xfrm>
+          <a:prstGeom prst="line">
+            <a:avLst/>
+          </a:prstGeom>
+          <a:ln w="22225">
+            <a:solidFill>
+              <a:srgbClr val="2F5597"/>
+            </a:solidFill>
+            <a:tailEnd type="triangle" w="med" h="med"/>
+          </a:ln>
+        </p:spPr>
+        <p:style>
+          <a:lnRef idx="2">
+            <a:schemeClr val="accent1"/>
+          </a:lnRef>
+          <a:fillRef idx="0">
+            <a:schemeClr val="accent1"/>
+          </a:fillRef>
+          <a:effectRef idx="1">
+            <a:schemeClr val="accent1"/>
+          </a:effectRef>
+          <a:fontRef idx="minor">
+            <a:schemeClr val="tx1"/>
+          </a:fontRef>
+        </p:style>
+      </p:cxnSp>
+      <p:sp>
+        <p:nvSpPr>
+          <p:cNvPr id="54" name="Rounded Rectangle 53"/>
+          <p:cNvSpPr/>
+          <p:nvPr/>
+        </p:nvSpPr>
+        <p:spPr>
+          <a:xfrm>
+            <a:off x="12024360" y="3108960"/>
+            <a:ext cx="3794760" cy="402336"/>
+          </a:xfrm>
+          <a:prstGeom prst="roundRect">
+            <a:avLst>
+              <a:gd name="adj" fmla="val 12000"/>
+            </a:avLst>
+          </a:prstGeom>
+          <a:solidFill>
+            <a:srgbClr val="FFFFFF"/>
+          </a:solidFill>
+          <a:ln w="15875">
+            <a:solidFill>
+              <a:srgbClr val="2F5597"/>
+            </a:solidFill>
+          </a:ln>
+          <a:effectLst/>
+        </p:spPr>
+        <p:style>
+          <a:lnRef idx="1">
+            <a:schemeClr val="accent1"/>
+          </a:lnRef>
+          <a:fillRef idx="3">
+            <a:schemeClr val="accent1"/>
+          </a:fillRef>
+          <a:effectRef idx="2">
+            <a:schemeClr val="accent1"/>
+          </a:effectRef>
+          <a:fontRef idx="minor">
+            <a:schemeClr val="lt1"/>
+          </a:fontRef>
+        </p:style>
+        <p:txBody>
+          <a:bodyPr rtlCol="0" anchor="ctr" wrap="square" lIns="45720" rIns="45720" tIns="18288" bIns="18288"/>
+          <a:lstStyle/>
+          <a:p>
+            <a:pPr algn="ctr"/>
+            <a:r>
+              <a:rPr sz="1150" b="1">
                 <a:solidFill>
                   <a:srgbClr val="1A1A1A"/>
                 </a:solidFill>
                 <a:latin typeface="Calibri"/>
               </a:rPr>
-              <a:t>colour clearly matches one kit result</a:t>
-            </a:r>
-          </a:p>
-          <a:p>
-            <a:pPr marL="292608" indent="-256032">
-              <a:spcAft>
-                <a:spcPts val="700"/>
-              </a:spcAft>
-              <a:buFont typeface="Arial"/>
-              <a:buChar char="•"/>
-            </a:pPr>
-            <a:r>
-              <a:rPr b="1" sz="1600">
+              <a:t>2. Photo sharp, no shine?</a:t>
+            </a:r>
+          </a:p>
+        </p:txBody>
+      </p:sp>
+      <p:cxnSp>
+        <p:nvCxnSpPr>
+          <p:cNvPr id="55" name="Connector 54"/>
+          <p:cNvCxnSpPr/>
+          <p:nvPr/>
+        </p:nvCxnSpPr>
+        <p:spPr>
+          <a:xfrm>
+            <a:off x="15819120" y="3310128"/>
+            <a:ext cx="228600" cy="0"/>
+          </a:xfrm>
+          <a:prstGeom prst="line">
+            <a:avLst/>
+          </a:prstGeom>
+          <a:ln w="22225">
+            <a:solidFill>
+              <a:srgbClr val="7030A0"/>
+            </a:solidFill>
+            <a:tailEnd type="triangle" w="med" h="med"/>
+          </a:ln>
+        </p:spPr>
+        <p:style>
+          <a:lnRef idx="2">
+            <a:schemeClr val="accent1"/>
+          </a:lnRef>
+          <a:fillRef idx="0">
+            <a:schemeClr val="accent1"/>
+          </a:fillRef>
+          <a:effectRef idx="1">
+            <a:schemeClr val="accent1"/>
+          </a:effectRef>
+          <a:fontRef idx="minor">
+            <a:schemeClr val="tx1"/>
+          </a:fontRef>
+        </p:style>
+      </p:cxnSp>
+      <p:sp>
+        <p:nvSpPr>
+          <p:cNvPr id="56" name="Rounded Rectangle 55"/>
+          <p:cNvSpPr/>
+          <p:nvPr/>
+        </p:nvSpPr>
+        <p:spPr>
+          <a:xfrm>
+            <a:off x="16047720" y="3145536"/>
+            <a:ext cx="1417320" cy="329184"/>
+          </a:xfrm>
+          <a:prstGeom prst="roundRect">
+            <a:avLst>
+              <a:gd name="adj" fmla="val 12000"/>
+            </a:avLst>
+          </a:prstGeom>
+          <a:solidFill>
+            <a:srgbClr val="E6C8F5"/>
+          </a:solidFill>
+          <a:ln w="15875">
+            <a:solidFill>
+              <a:srgbClr val="7030A0"/>
+            </a:solidFill>
+          </a:ln>
+          <a:effectLst/>
+        </p:spPr>
+        <p:style>
+          <a:lnRef idx="1">
+            <a:schemeClr val="accent1"/>
+          </a:lnRef>
+          <a:fillRef idx="3">
+            <a:schemeClr val="accent1"/>
+          </a:fillRef>
+          <a:effectRef idx="2">
+            <a:schemeClr val="accent1"/>
+          </a:effectRef>
+          <a:fontRef idx="minor">
+            <a:schemeClr val="lt1"/>
+          </a:fontRef>
+        </p:style>
+        <p:txBody>
+          <a:bodyPr rtlCol="0" anchor="ctr" wrap="square" lIns="45720" rIns="45720" tIns="18288" bIns="18288"/>
+          <a:lstStyle/>
+          <a:p>
+            <a:pPr algn="ctr"/>
+            <a:r>
+              <a:rPr sz="950" b="1">
                 <a:solidFill>
                   <a:srgbClr val="1A1A1A"/>
                 </a:solidFill>
                 <a:latin typeface="Calibri"/>
               </a:rPr>
-              <a:t>NOT SURE: </a:t>
-            </a:r>
-            <a:r>
-              <a:rPr sz="1600">
+              <a:t>No → NOT SURE</a:t>
+            </a:r>
+          </a:p>
+        </p:txBody>
+      </p:sp>
+      <p:cxnSp>
+        <p:nvCxnSpPr>
+          <p:cNvPr id="57" name="Connector 56"/>
+          <p:cNvCxnSpPr/>
+          <p:nvPr/>
+        </p:nvCxnSpPr>
+        <p:spPr>
+          <a:xfrm>
+            <a:off x="13917168" y="3511296"/>
+            <a:ext cx="0" cy="146304"/>
+          </a:xfrm>
+          <a:prstGeom prst="line">
+            <a:avLst/>
+          </a:prstGeom>
+          <a:ln w="22225">
+            <a:solidFill>
+              <a:srgbClr val="2F5597"/>
+            </a:solidFill>
+            <a:tailEnd type="triangle" w="med" h="med"/>
+          </a:ln>
+        </p:spPr>
+        <p:style>
+          <a:lnRef idx="2">
+            <a:schemeClr val="accent1"/>
+          </a:lnRef>
+          <a:fillRef idx="0">
+            <a:schemeClr val="accent1"/>
+          </a:fillRef>
+          <a:effectRef idx="1">
+            <a:schemeClr val="accent1"/>
+          </a:effectRef>
+          <a:fontRef idx="minor">
+            <a:schemeClr val="tx1"/>
+          </a:fontRef>
+        </p:style>
+      </p:cxnSp>
+      <p:sp>
+        <p:nvSpPr>
+          <p:cNvPr id="58" name="Rounded Rectangle 57"/>
+          <p:cNvSpPr/>
+          <p:nvPr/>
+        </p:nvSpPr>
+        <p:spPr>
+          <a:xfrm>
+            <a:off x="12024360" y="3657600"/>
+            <a:ext cx="3794760" cy="402336"/>
+          </a:xfrm>
+          <a:prstGeom prst="roundRect">
+            <a:avLst>
+              <a:gd name="adj" fmla="val 12000"/>
+            </a:avLst>
+          </a:prstGeom>
+          <a:solidFill>
+            <a:srgbClr val="FFFFFF"/>
+          </a:solidFill>
+          <a:ln w="15875">
+            <a:solidFill>
+              <a:srgbClr val="2F5597"/>
+            </a:solidFill>
+          </a:ln>
+          <a:effectLst/>
+        </p:spPr>
+        <p:style>
+          <a:lnRef idx="1">
+            <a:schemeClr val="accent1"/>
+          </a:lnRef>
+          <a:fillRef idx="3">
+            <a:schemeClr val="accent1"/>
+          </a:fillRef>
+          <a:effectRef idx="2">
+            <a:schemeClr val="accent1"/>
+          </a:effectRef>
+          <a:fontRef idx="minor">
+            <a:schemeClr val="lt1"/>
+          </a:fontRef>
+        </p:style>
+        <p:txBody>
+          <a:bodyPr rtlCol="0" anchor="ctr" wrap="square" lIns="45720" rIns="45720" tIns="18288" bIns="18288"/>
+          <a:lstStyle/>
+          <a:p>
+            <a:pPr algn="ctr"/>
+            <a:r>
+              <a:rPr sz="1150" b="1">
                 <a:solidFill>
                   <a:srgbClr val="1A1A1A"/>
                 </a:solidFill>
                 <a:latin typeface="Calibri"/>
               </a:rPr>
-              <a:t>colour card not found in the photo</a:t>
-            </a:r>
-          </a:p>
-          <a:p>
-            <a:pPr marL="292608" indent="-256032">
-              <a:spcAft>
-                <a:spcPts val="700"/>
-              </a:spcAft>
-              <a:buFont typeface="Arial"/>
-              <a:buChar char="•"/>
-            </a:pPr>
-            <a:r>
-              <a:rPr b="1" sz="1600">
+              <a:t>3. Closest kit colour: difference ≤ 14?</a:t>
+            </a:r>
+          </a:p>
+        </p:txBody>
+      </p:sp>
+      <p:cxnSp>
+        <p:nvCxnSpPr>
+          <p:cNvPr id="59" name="Connector 58"/>
+          <p:cNvCxnSpPr/>
+          <p:nvPr/>
+        </p:nvCxnSpPr>
+        <p:spPr>
+          <a:xfrm>
+            <a:off x="15819120" y="3858768"/>
+            <a:ext cx="228600" cy="0"/>
+          </a:xfrm>
+          <a:prstGeom prst="line">
+            <a:avLst/>
+          </a:prstGeom>
+          <a:ln w="22225">
+            <a:solidFill>
+              <a:srgbClr val="7030A0"/>
+            </a:solidFill>
+            <a:tailEnd type="triangle" w="med" h="med"/>
+          </a:ln>
+        </p:spPr>
+        <p:style>
+          <a:lnRef idx="2">
+            <a:schemeClr val="accent1"/>
+          </a:lnRef>
+          <a:fillRef idx="0">
+            <a:schemeClr val="accent1"/>
+          </a:fillRef>
+          <a:effectRef idx="1">
+            <a:schemeClr val="accent1"/>
+          </a:effectRef>
+          <a:fontRef idx="minor">
+            <a:schemeClr val="tx1"/>
+          </a:fontRef>
+        </p:style>
+      </p:cxnSp>
+      <p:sp>
+        <p:nvSpPr>
+          <p:cNvPr id="60" name="Rounded Rectangle 59"/>
+          <p:cNvSpPr/>
+          <p:nvPr/>
+        </p:nvSpPr>
+        <p:spPr>
+          <a:xfrm>
+            <a:off x="16047720" y="3694176"/>
+            <a:ext cx="1417320" cy="329184"/>
+          </a:xfrm>
+          <a:prstGeom prst="roundRect">
+            <a:avLst>
+              <a:gd name="adj" fmla="val 12000"/>
+            </a:avLst>
+          </a:prstGeom>
+          <a:solidFill>
+            <a:srgbClr val="E6C8F5"/>
+          </a:solidFill>
+          <a:ln w="15875">
+            <a:solidFill>
+              <a:srgbClr val="7030A0"/>
+            </a:solidFill>
+          </a:ln>
+          <a:effectLst/>
+        </p:spPr>
+        <p:style>
+          <a:lnRef idx="1">
+            <a:schemeClr val="accent1"/>
+          </a:lnRef>
+          <a:fillRef idx="3">
+            <a:schemeClr val="accent1"/>
+          </a:fillRef>
+          <a:effectRef idx="2">
+            <a:schemeClr val="accent1"/>
+          </a:effectRef>
+          <a:fontRef idx="minor">
+            <a:schemeClr val="lt1"/>
+          </a:fontRef>
+        </p:style>
+        <p:txBody>
+          <a:bodyPr rtlCol="0" anchor="ctr" wrap="square" lIns="45720" rIns="45720" tIns="18288" bIns="18288"/>
+          <a:lstStyle/>
+          <a:p>
+            <a:pPr algn="ctr"/>
+            <a:r>
+              <a:rPr sz="950" b="1">
                 <a:solidFill>
                   <a:srgbClr val="1A1A1A"/>
                 </a:solidFill>
                 <a:latin typeface="Calibri"/>
               </a:rPr>
-              <a:t>NOT SURE: </a:t>
-            </a:r>
-            <a:r>
-              <a:rPr sz="1600">
+              <a:t>No → NOT SURE</a:t>
+            </a:r>
+          </a:p>
+        </p:txBody>
+      </p:sp>
+      <p:cxnSp>
+        <p:nvCxnSpPr>
+          <p:cNvPr id="61" name="Connector 60"/>
+          <p:cNvCxnSpPr/>
+          <p:nvPr/>
+        </p:nvCxnSpPr>
+        <p:spPr>
+          <a:xfrm>
+            <a:off x="13917168" y="4059936"/>
+            <a:ext cx="0" cy="146304"/>
+          </a:xfrm>
+          <a:prstGeom prst="line">
+            <a:avLst/>
+          </a:prstGeom>
+          <a:ln w="22225">
+            <a:solidFill>
+              <a:srgbClr val="2F5597"/>
+            </a:solidFill>
+            <a:tailEnd type="triangle" w="med" h="med"/>
+          </a:ln>
+        </p:spPr>
+        <p:style>
+          <a:lnRef idx="2">
+            <a:schemeClr val="accent1"/>
+          </a:lnRef>
+          <a:fillRef idx="0">
+            <a:schemeClr val="accent1"/>
+          </a:fillRef>
+          <a:effectRef idx="1">
+            <a:schemeClr val="accent1"/>
+          </a:effectRef>
+          <a:fontRef idx="minor">
+            <a:schemeClr val="tx1"/>
+          </a:fontRef>
+        </p:style>
+      </p:cxnSp>
+      <p:sp>
+        <p:nvSpPr>
+          <p:cNvPr id="62" name="Rounded Rectangle 61"/>
+          <p:cNvSpPr/>
+          <p:nvPr/>
+        </p:nvSpPr>
+        <p:spPr>
+          <a:xfrm>
+            <a:off x="12024360" y="4206240"/>
+            <a:ext cx="3794760" cy="402336"/>
+          </a:xfrm>
+          <a:prstGeom prst="roundRect">
+            <a:avLst>
+              <a:gd name="adj" fmla="val 12000"/>
+            </a:avLst>
+          </a:prstGeom>
+          <a:solidFill>
+            <a:srgbClr val="FFFFFF"/>
+          </a:solidFill>
+          <a:ln w="15875">
+            <a:solidFill>
+              <a:srgbClr val="2F5597"/>
+            </a:solidFill>
+          </a:ln>
+          <a:effectLst/>
+        </p:spPr>
+        <p:style>
+          <a:lnRef idx="1">
+            <a:schemeClr val="accent1"/>
+          </a:lnRef>
+          <a:fillRef idx="3">
+            <a:schemeClr val="accent1"/>
+          </a:fillRef>
+          <a:effectRef idx="2">
+            <a:schemeClr val="accent1"/>
+          </a:effectRef>
+          <a:fontRef idx="minor">
+            <a:schemeClr val="lt1"/>
+          </a:fontRef>
+        </p:style>
+        <p:txBody>
+          <a:bodyPr rtlCol="0" anchor="ctr" wrap="square" lIns="45720" rIns="45720" tIns="18288" bIns="18288"/>
+          <a:lstStyle/>
+          <a:p>
+            <a:pPr algn="ctr"/>
+            <a:r>
+              <a:rPr sz="1150" b="1">
                 <a:solidFill>
                   <a:srgbClr val="1A1A1A"/>
                 </a:solidFill>
                 <a:latin typeface="Calibri"/>
               </a:rPr>
-              <a:t>photo is blurry or shiny</a:t>
-            </a:r>
-          </a:p>
-          <a:p>
-            <a:pPr marL="292608" indent="-256032">
-              <a:spcAft>
-                <a:spcPts val="700"/>
-              </a:spcAft>
-              <a:buFont typeface="Arial"/>
-              <a:buChar char="•"/>
-            </a:pPr>
-            <a:r>
-              <a:rPr b="1" sz="1600">
+              <a:t>4. Clear winner: 2nd best ≥ 4 further?</a:t>
+            </a:r>
+          </a:p>
+        </p:txBody>
+      </p:sp>
+      <p:cxnSp>
+        <p:nvCxnSpPr>
+          <p:cNvPr id="63" name="Connector 62"/>
+          <p:cNvCxnSpPr/>
+          <p:nvPr/>
+        </p:nvCxnSpPr>
+        <p:spPr>
+          <a:xfrm>
+            <a:off x="15819120" y="4407407"/>
+            <a:ext cx="228600" cy="0"/>
+          </a:xfrm>
+          <a:prstGeom prst="line">
+            <a:avLst/>
+          </a:prstGeom>
+          <a:ln w="22225">
+            <a:solidFill>
+              <a:srgbClr val="7030A0"/>
+            </a:solidFill>
+            <a:tailEnd type="triangle" w="med" h="med"/>
+          </a:ln>
+        </p:spPr>
+        <p:style>
+          <a:lnRef idx="2">
+            <a:schemeClr val="accent1"/>
+          </a:lnRef>
+          <a:fillRef idx="0">
+            <a:schemeClr val="accent1"/>
+          </a:fillRef>
+          <a:effectRef idx="1">
+            <a:schemeClr val="accent1"/>
+          </a:effectRef>
+          <a:fontRef idx="minor">
+            <a:schemeClr val="tx1"/>
+          </a:fontRef>
+        </p:style>
+      </p:cxnSp>
+      <p:sp>
+        <p:nvSpPr>
+          <p:cNvPr id="64" name="Rounded Rectangle 63"/>
+          <p:cNvSpPr/>
+          <p:nvPr/>
+        </p:nvSpPr>
+        <p:spPr>
+          <a:xfrm>
+            <a:off x="16047720" y="4242816"/>
+            <a:ext cx="1417320" cy="329184"/>
+          </a:xfrm>
+          <a:prstGeom prst="roundRect">
+            <a:avLst>
+              <a:gd name="adj" fmla="val 12000"/>
+            </a:avLst>
+          </a:prstGeom>
+          <a:solidFill>
+            <a:srgbClr val="E6C8F5"/>
+          </a:solidFill>
+          <a:ln w="15875">
+            <a:solidFill>
+              <a:srgbClr val="7030A0"/>
+            </a:solidFill>
+          </a:ln>
+          <a:effectLst/>
+        </p:spPr>
+        <p:style>
+          <a:lnRef idx="1">
+            <a:schemeClr val="accent1"/>
+          </a:lnRef>
+          <a:fillRef idx="3">
+            <a:schemeClr val="accent1"/>
+          </a:fillRef>
+          <a:effectRef idx="2">
+            <a:schemeClr val="accent1"/>
+          </a:effectRef>
+          <a:fontRef idx="minor">
+            <a:schemeClr val="lt1"/>
+          </a:fontRef>
+        </p:style>
+        <p:txBody>
+          <a:bodyPr rtlCol="0" anchor="ctr" wrap="square" lIns="45720" rIns="45720" tIns="18288" bIns="18288"/>
+          <a:lstStyle/>
+          <a:p>
+            <a:pPr algn="ctr"/>
+            <a:r>
+              <a:rPr sz="950" b="1">
                 <a:solidFill>
                   <a:srgbClr val="1A1A1A"/>
                 </a:solidFill>
                 <a:latin typeface="Calibri"/>
               </a:rPr>
-              <a:t>NOT SURE: </a:t>
-            </a:r>
-            <a:r>
-              <a:rPr sz="1600">
+              <a:t>No → NOT SURE</a:t>
+            </a:r>
+          </a:p>
+        </p:txBody>
+      </p:sp>
+      <p:cxnSp>
+        <p:nvCxnSpPr>
+          <p:cNvPr id="65" name="Connector 64"/>
+          <p:cNvCxnSpPr/>
+          <p:nvPr/>
+        </p:nvCxnSpPr>
+        <p:spPr>
+          <a:xfrm>
+            <a:off x="13917168" y="4608576"/>
+            <a:ext cx="0" cy="164591"/>
+          </a:xfrm>
+          <a:prstGeom prst="line">
+            <a:avLst/>
+          </a:prstGeom>
+          <a:ln w="22225">
+            <a:solidFill>
+              <a:srgbClr val="2F5597"/>
+            </a:solidFill>
+            <a:tailEnd type="triangle" w="med" h="med"/>
+          </a:ln>
+        </p:spPr>
+        <p:style>
+          <a:lnRef idx="2">
+            <a:schemeClr val="accent1"/>
+          </a:lnRef>
+          <a:fillRef idx="0">
+            <a:schemeClr val="accent1"/>
+          </a:fillRef>
+          <a:effectRef idx="1">
+            <a:schemeClr val="accent1"/>
+          </a:effectRef>
+          <a:fontRef idx="minor">
+            <a:schemeClr val="tx1"/>
+          </a:fontRef>
+        </p:style>
+      </p:cxnSp>
+      <p:sp>
+        <p:nvSpPr>
+          <p:cNvPr id="66" name="Rounded Rectangle 65"/>
+          <p:cNvSpPr/>
+          <p:nvPr/>
+        </p:nvSpPr>
+        <p:spPr>
+          <a:xfrm>
+            <a:off x="12024360" y="4773167"/>
+            <a:ext cx="5440680" cy="384048"/>
+          </a:xfrm>
+          <a:prstGeom prst="roundRect">
+            <a:avLst>
+              <a:gd name="adj" fmla="val 12000"/>
+            </a:avLst>
+          </a:prstGeom>
+          <a:solidFill>
+            <a:srgbClr val="E2F0D9"/>
+          </a:solidFill>
+          <a:ln w="15875">
+            <a:solidFill>
+              <a:srgbClr val="548235"/>
+            </a:solidFill>
+          </a:ln>
+          <a:effectLst/>
+        </p:spPr>
+        <p:style>
+          <a:lnRef idx="1">
+            <a:schemeClr val="accent1"/>
+          </a:lnRef>
+          <a:fillRef idx="3">
+            <a:schemeClr val="accent1"/>
+          </a:fillRef>
+          <a:effectRef idx="2">
+            <a:schemeClr val="accent1"/>
+          </a:effectRef>
+          <a:fontRef idx="minor">
+            <a:schemeClr val="lt1"/>
+          </a:fontRef>
+        </p:style>
+        <p:txBody>
+          <a:bodyPr rtlCol="0" anchor="ctr" wrap="square" lIns="45720" rIns="45720" tIns="18288" bIns="18288"/>
+          <a:lstStyle/>
+          <a:p>
+            <a:pPr algn="ctr"/>
+            <a:r>
+              <a:rPr sz="1100" b="1">
                 <a:solidFill>
                   <a:srgbClr val="1A1A1A"/>
                 </a:solidFill>
                 <a:latin typeface="Calibri"/>
               </a:rPr>
-              <a:t>colour does not match any result</a:t>
-            </a:r>
-          </a:p>
-          <a:p>
-            <a:pPr marL="292608" indent="-256032">
-              <a:spcAft>
-                <a:spcPts val="700"/>
-              </a:spcAft>
-              <a:buFont typeface="Arial"/>
-              <a:buChar char="•"/>
-            </a:pPr>
-            <a:r>
-              <a:rPr b="1" sz="1600">
-                <a:solidFill>
-                  <a:srgbClr val="1A1A1A"/>
-                </a:solidFill>
-                <a:latin typeface="Calibri"/>
-              </a:rPr>
-              <a:t>NOT SURE: </a:t>
-            </a:r>
-            <a:r>
-              <a:rPr sz="1600">
-                <a:solidFill>
-                  <a:srgbClr val="1A1A1A"/>
-                </a:solidFill>
-                <a:latin typeface="Calibri"/>
-              </a:rPr>
-              <a:t>colour is in between two results</a:t>
-            </a:r>
-          </a:p>
-          <a:p>
-            <a:pPr marL="292608" indent="-256032">
-              <a:spcAft>
-                <a:spcPts val="700"/>
-              </a:spcAft>
-              <a:buFont typeface="Arial"/>
-              <a:buChar char="•"/>
-            </a:pPr>
-            <a:r>
-              <a:rPr b="1" sz="1600">
-                <a:solidFill>
-                  <a:srgbClr val="1A1A1A"/>
-                </a:solidFill>
-                <a:latin typeface="Calibri"/>
-              </a:rPr>
-              <a:t>"% sure": </a:t>
-            </a:r>
-            <a:r>
-              <a:rPr sz="1600">
-                <a:solidFill>
-                  <a:srgbClr val="1A1A1A"/>
-                </a:solidFill>
-                <a:latin typeface="Calibri"/>
-              </a:rPr>
-              <a:t>how clearly it matches the best result</a:t>
-            </a:r>
-          </a:p>
-        </p:txBody>
-      </p:sp>
-      <p:sp>
-        <p:nvSpPr>
-          <p:cNvPr id="51" name="TextBox 50"/>
+              <a:t>Yes → POSITIVE / NEGATIVE + "% sure"   (limits are set per kit)</a:t>
+            </a:r>
+          </a:p>
+        </p:txBody>
+      </p:sp>
+      <p:sp>
+        <p:nvSpPr>
+          <p:cNvPr id="67" name="TextBox 66"/>
           <p:cNvSpPr txBox="1"/>
           <p:nvPr/>
         </p:nvSpPr>
@@ -9459,7 +10110,7 @@
       </p:sp>
       <p:sp>
         <p:nvSpPr>
-          <p:cNvPr id="52" name="TextBox 51"/>
+          <p:cNvPr id="68" name="TextBox 67"/>
           <p:cNvSpPr txBox="1"/>
           <p:nvPr/>
         </p:nvSpPr>
@@ -9494,7 +10145,7 @@
       </p:sp>
       <p:sp>
         <p:nvSpPr>
-          <p:cNvPr id="53" name="TextBox 52"/>
+          <p:cNvPr id="69" name="TextBox 68"/>
           <p:cNvSpPr txBox="1"/>
           <p:nvPr/>
         </p:nvSpPr>
@@ -9598,7 +10249,7 @@
       </p:sp>
       <p:sp>
         <p:nvSpPr>
-          <p:cNvPr id="54" name="TextBox 53"/>
+          <p:cNvPr id="70" name="TextBox 69"/>
           <p:cNvSpPr txBox="1"/>
           <p:nvPr/>
         </p:nvSpPr>
@@ -9633,7 +10284,7 @@
       </p:sp>
       <p:sp>
         <p:nvSpPr>
-          <p:cNvPr id="55" name="TextBox 54"/>
+          <p:cNvPr id="71" name="TextBox 70"/>
           <p:cNvSpPr txBox="1"/>
           <p:nvPr/>
         </p:nvSpPr>
@@ -9668,7 +10319,7 @@
       </p:sp>
       <p:sp>
         <p:nvSpPr>
-          <p:cNvPr id="56" name="Rounded Rectangle 55"/>
+          <p:cNvPr id="72" name="Rounded Rectangle 71"/>
           <p:cNvSpPr/>
           <p:nvPr/>
         </p:nvSpPr>
@@ -9737,7 +10388,7 @@
       </p:sp>
       <p:cxnSp>
         <p:nvCxnSpPr>
-          <p:cNvPr id="57" name="Connector 56"/>
+          <p:cNvPr id="73" name="Connector 72"/>
           <p:cNvCxnSpPr/>
           <p:nvPr/>
         </p:nvCxnSpPr>
@@ -9773,7 +10424,7 @@
       </p:cxnSp>
       <p:sp>
         <p:nvSpPr>
-          <p:cNvPr id="58" name="Rounded Rectangle 57"/>
+          <p:cNvPr id="74" name="Rounded Rectangle 73"/>
           <p:cNvSpPr/>
           <p:nvPr/>
         </p:nvSpPr>
@@ -9842,7 +10493,7 @@
       </p:sp>
       <p:cxnSp>
         <p:nvCxnSpPr>
-          <p:cNvPr id="59" name="Connector 58"/>
+          <p:cNvPr id="75" name="Connector 74"/>
           <p:cNvCxnSpPr/>
           <p:nvPr/>
         </p:nvCxnSpPr>
@@ -9878,7 +10529,7 @@
       </p:cxnSp>
       <p:sp>
         <p:nvSpPr>
-          <p:cNvPr id="60" name="Rounded Rectangle 59"/>
+          <p:cNvPr id="76" name="Rounded Rectangle 75"/>
           <p:cNvSpPr/>
           <p:nvPr/>
         </p:nvSpPr>
@@ -9947,7 +10598,7 @@
       </p:sp>
       <p:cxnSp>
         <p:nvCxnSpPr>
-          <p:cNvPr id="61" name="Connector 60"/>
+          <p:cNvPr id="77" name="Connector 76"/>
           <p:cNvCxnSpPr/>
           <p:nvPr/>
         </p:nvCxnSpPr>
@@ -9983,7 +10634,7 @@
       </p:cxnSp>
       <p:sp>
         <p:nvSpPr>
-          <p:cNvPr id="62" name="Rounded Rectangle 61"/>
+          <p:cNvPr id="78" name="Rounded Rectangle 77"/>
           <p:cNvSpPr/>
           <p:nvPr/>
         </p:nvSpPr>
@@ -10052,7 +10703,7 @@
       </p:sp>
       <p:sp>
         <p:nvSpPr>
-          <p:cNvPr id="63" name="Rounded Rectangle 62"/>
+          <p:cNvPr id="79" name="Rounded Rectangle 78"/>
           <p:cNvSpPr/>
           <p:nvPr/>
         </p:nvSpPr>
@@ -10109,7 +10760,7 @@
       </p:sp>
       <p:sp>
         <p:nvSpPr>
-          <p:cNvPr id="64" name="TextBox 63"/>
+          <p:cNvPr id="80" name="TextBox 79"/>
           <p:cNvSpPr txBox="1"/>
           <p:nvPr/>
         </p:nvSpPr>
@@ -10144,7 +10795,7 @@
       </p:sp>
       <p:sp>
         <p:nvSpPr>
-          <p:cNvPr id="65" name="Rounded Rectangle 64"/>
+          <p:cNvPr id="81" name="Rounded Rectangle 80"/>
           <p:cNvSpPr/>
           <p:nvPr/>
         </p:nvSpPr>
@@ -10201,7 +10852,7 @@
       </p:sp>
       <p:sp>
         <p:nvSpPr>
-          <p:cNvPr id="66" name="Rounded Rectangle 65"/>
+          <p:cNvPr id="82" name="Rounded Rectangle 81"/>
           <p:cNvSpPr/>
           <p:nvPr/>
         </p:nvSpPr>
@@ -10258,7 +10909,7 @@
       </p:sp>
       <p:sp>
         <p:nvSpPr>
-          <p:cNvPr id="67" name="Rounded Rectangle 66"/>
+          <p:cNvPr id="83" name="Rounded Rectangle 82"/>
           <p:cNvSpPr/>
           <p:nvPr/>
         </p:nvSpPr>
@@ -10327,7 +10978,7 @@
       </p:sp>
       <p:sp>
         <p:nvSpPr>
-          <p:cNvPr id="68" name="Rounded Rectangle 67"/>
+          <p:cNvPr id="84" name="Rounded Rectangle 83"/>
           <p:cNvSpPr/>
           <p:nvPr/>
         </p:nvSpPr>
@@ -10396,7 +11047,7 @@
       </p:sp>
       <p:sp>
         <p:nvSpPr>
-          <p:cNvPr id="69" name="Rounded Rectangle 68"/>
+          <p:cNvPr id="85" name="Rounded Rectangle 84"/>
           <p:cNvSpPr/>
           <p:nvPr/>
         </p:nvSpPr>
@@ -10453,7 +11104,7 @@
       </p:sp>
       <p:sp>
         <p:nvSpPr>
-          <p:cNvPr id="70" name="Rounded Rectangle 69"/>
+          <p:cNvPr id="86" name="Rounded Rectangle 85"/>
           <p:cNvSpPr/>
           <p:nvPr/>
         </p:nvSpPr>
@@ -10510,7 +11161,7 @@
       </p:sp>
       <p:cxnSp>
         <p:nvCxnSpPr>
-          <p:cNvPr id="71" name="Connector 70"/>
+          <p:cNvPr id="87" name="Connector 86"/>
           <p:cNvCxnSpPr/>
           <p:nvPr/>
         </p:nvCxnSpPr>
@@ -10546,7 +11197,7 @@
       </p:cxnSp>
       <p:cxnSp>
         <p:nvCxnSpPr>
-          <p:cNvPr id="72" name="Connector 71"/>
+          <p:cNvPr id="88" name="Connector 87"/>
           <p:cNvCxnSpPr/>
           <p:nvPr/>
         </p:nvCxnSpPr>
@@ -10582,7 +11233,7 @@
       </p:cxnSp>
       <p:cxnSp>
         <p:nvCxnSpPr>
-          <p:cNvPr id="73" name="Connector 72"/>
+          <p:cNvPr id="89" name="Connector 88"/>
           <p:cNvCxnSpPr/>
           <p:nvPr/>
         </p:nvCxnSpPr>
@@ -10618,7 +11269,7 @@
       </p:cxnSp>
       <p:cxnSp>
         <p:nvCxnSpPr>
-          <p:cNvPr id="74" name="Connector 73"/>
+          <p:cNvPr id="90" name="Connector 89"/>
           <p:cNvCxnSpPr/>
           <p:nvPr/>
         </p:nvCxnSpPr>
@@ -10654,7 +11305,7 @@
       </p:cxnSp>
       <p:cxnSp>
         <p:nvCxnSpPr>
-          <p:cNvPr id="75" name="Connector 74"/>
+          <p:cNvPr id="91" name="Connector 90"/>
           <p:cNvCxnSpPr/>
           <p:nvPr/>
         </p:nvCxnSpPr>
@@ -10690,7 +11341,7 @@
       </p:cxnSp>
       <p:sp>
         <p:nvSpPr>
-          <p:cNvPr id="76" name="TextBox 75"/>
+          <p:cNvPr id="92" name="TextBox 91"/>
           <p:cNvSpPr txBox="1"/>
           <p:nvPr/>
         </p:nvSpPr>
@@ -11755,7 +12406,7 @@
                           <a:cs typeface="Calibri (MS)"/>
                           <a:sym typeface="Calibri (MS)"/>
                         </a:rPr>
-                        <a:t>Different kits and phones</a:t>
+                        <a:t>Kit from another maker or batch</a:t>
                       </a:r>
                       <a:endParaRPr lang="en-US" sz="1100"/>
                     </a:p>
@@ -11820,7 +12471,7 @@
                           <a:cs typeface="Calibri (MS)"/>
                           <a:sym typeface="Calibri (MS)"/>
                         </a:rPr>
-                        <a:t>Kit settings + colours fixed every photo</a:t>
+                        <a:t>Own profile per maker/batch; else NOT SURE</a:t>
                       </a:r>
                       <a:endParaRPr lang="en-US" sz="1100"/>
                     </a:p>
@@ -12397,13 +13048,13 @@
           <a:p>
             <a:pPr marL="292608" indent="-256032">
               <a:spcAft>
-                <a:spcPts val="400"/>
+                <a:spcPts val="300"/>
               </a:spcAft>
               <a:buFont typeface="Arial"/>
               <a:buChar char="•"/>
             </a:pPr>
             <a:r>
-              <a:rPr b="1" sz="1800">
+              <a:rPr b="1" sz="1700">
                 <a:solidFill>
                   <a:srgbClr val="1A1A1A"/>
                 </a:solidFill>
@@ -12412,7 +13063,7 @@
               <a:t>Technical - </a:t>
             </a:r>
             <a:r>
-              <a:rPr sz="1800">
+              <a:rPr sz="1700">
                 <a:solidFill>
                   <a:srgbClr val="1A1A1A"/>
                 </a:solidFill>
@@ -12424,13 +13075,13 @@
           <a:p>
             <a:pPr marL="292608" indent="-256032">
               <a:spcAft>
-                <a:spcPts val="400"/>
+                <a:spcPts val="300"/>
               </a:spcAft>
               <a:buFont typeface="Arial"/>
               <a:buChar char="•"/>
             </a:pPr>
             <a:r>
-              <a:rPr b="1" sz="1800">
+              <a:rPr b="1" sz="1700">
                 <a:solidFill>
                   <a:srgbClr val="1A1A1A"/>
                 </a:solidFill>
@@ -12439,25 +13090,25 @@
               <a:t>Easy to use - </a:t>
             </a:r>
             <a:r>
-              <a:rPr sz="1800">
+              <a:rPr sz="1700">
                 <a:solidFill>
                   <a:srgbClr val="1A1A1A"/>
                 </a:solidFill>
                 <a:latin typeface="Calibri"/>
               </a:rPr>
-              <a:t>officer takes one photo, gets the result in seconds.</a:t>
+              <a:t>one photo, result in seconds; card can be printed on the kit pouch.</a:t>
             </a:r>
           </a:p>
           <a:p>
             <a:pPr marL="292608" indent="-256032">
               <a:spcAft>
-                <a:spcPts val="400"/>
+                <a:spcPts val="300"/>
               </a:spcAft>
               <a:buFont typeface="Arial"/>
               <a:buChar char="•"/>
             </a:pPr>
             <a:r>
-              <a:rPr b="1" sz="1800">
+              <a:rPr b="1" sz="1700">
                 <a:solidFill>
                   <a:srgbClr val="1A1A1A"/>
                 </a:solidFill>
@@ -12466,7 +13117,7 @@
               <a:t>Low cost - </a:t>
             </a:r>
             <a:r>
-              <a:rPr sz="1800">
+              <a:rPr sz="1700">
                 <a:solidFill>
                   <a:srgbClr val="1A1A1A"/>
                 </a:solidFill>
@@ -12478,28 +13129,28 @@
           <a:p>
             <a:pPr marL="292608" indent="-256032">
               <a:spcAft>
-                <a:spcPts val="400"/>
+                <a:spcPts val="300"/>
               </a:spcAft>
               <a:buFont typeface="Arial"/>
               <a:buChar char="•"/>
             </a:pPr>
             <a:r>
-              <a:rPr b="1" sz="1800">
+              <a:rPr b="1" sz="1700">
                 <a:solidFill>
                   <a:srgbClr val="1A1A1A"/>
                 </a:solidFill>
                 <a:latin typeface="Calibri"/>
               </a:rPr>
-              <a:t>Scalable - </a:t>
-            </a:r>
-            <a:r>
-              <a:rPr sz="1800">
+              <a:t>Data plan - </a:t>
+            </a:r>
+            <a:r>
+              <a:rPr sz="1700">
                 <a:solidFill>
                   <a:srgbClr val="1A1A1A"/>
                 </a:solidFill>
                 <a:latin typeface="Calibri"/>
               </a:rPr>
-              <a:t>add any new kit from the website; works on any Android phone.</a:t>
+              <a:t>each kit calibrated with ~250 real photos (5 lights × 50) at an FSL.</a:t>
             </a:r>
           </a:p>
         </p:txBody>
@@ -13193,7 +13844,7 @@
                 </a:solidFill>
                 <a:latin typeface="Calibri"/>
               </a:rPr>
-              <a:t>Proof of every test: time, place, officer, photo</a:t>
+              <a:t>Proof for field tests in ~1.2 lakh NDPS cases a year (NCRB 2023)</a:t>
             </a:r>
           </a:p>
           <a:p>
@@ -14260,13 +14911,13 @@
           <a:p>
             <a:pPr marL="292608" indent="-256032">
               <a:spcAft>
-                <a:spcPts val="600"/>
+                <a:spcPts val="400"/>
               </a:spcAft>
               <a:buFont typeface="Arial"/>
               <a:buChar char="•"/>
             </a:pPr>
             <a:r>
-              <a:rPr b="1" sz="1900">
+              <a:rPr b="1" sz="1800">
                 <a:solidFill>
                   <a:srgbClr val="1A1A1A"/>
                 </a:solidFill>
@@ -14275,7 +14926,7 @@
               <a:t>Works offline - </a:t>
             </a:r>
             <a:r>
-              <a:rPr sz="1900">
+              <a:rPr sz="1800">
                 <a:solidFill>
                   <a:srgbClr val="1A1A1A"/>
                 </a:solidFill>
@@ -14287,13 +14938,13 @@
           <a:p>
             <a:pPr marL="292608" indent="-256032">
               <a:spcAft>
-                <a:spcPts val="600"/>
+                <a:spcPts val="400"/>
               </a:spcAft>
               <a:buFont typeface="Arial"/>
               <a:buChar char="•"/>
             </a:pPr>
             <a:r>
-              <a:rPr b="1" sz="1900">
+              <a:rPr b="1" sz="1800">
                 <a:solidFill>
                   <a:srgbClr val="1A1A1A"/>
                 </a:solidFill>
@@ -14302,7 +14953,7 @@
               <a:t>Phone security chip - </a:t>
             </a:r>
             <a:r>
-              <a:rPr sz="1900">
+              <a:rPr sz="1800">
                 <a:solidFill>
                   <a:srgbClr val="1A1A1A"/>
                 </a:solidFill>
@@ -14314,13 +14965,13 @@
           <a:p>
             <a:pPr marL="292608" indent="-256032">
               <a:spcAft>
-                <a:spcPts val="600"/>
+                <a:spcPts val="400"/>
               </a:spcAft>
               <a:buFont typeface="Arial"/>
               <a:buChar char="•"/>
             </a:pPr>
             <a:r>
-              <a:rPr b="1" sz="1900">
+              <a:rPr b="1" sz="1800">
                 <a:solidFill>
                   <a:srgbClr val="1A1A1A"/>
                 </a:solidFill>
@@ -14329,7 +14980,7 @@
               <a:t>Link with police systems - </a:t>
             </a:r>
             <a:r>
-              <a:rPr sz="1900">
+              <a:rPr sz="1800">
                 <a:solidFill>
                   <a:srgbClr val="1A1A1A"/>
                 </a:solidFill>
@@ -14341,13 +14992,13 @@
           <a:p>
             <a:pPr marL="292608" indent="-256032">
               <a:spcAft>
-                <a:spcPts val="600"/>
+                <a:spcPts val="400"/>
               </a:spcAft>
               <a:buFont typeface="Arial"/>
               <a:buChar char="•"/>
             </a:pPr>
             <a:r>
-              <a:rPr b="1" sz="1900">
+              <a:rPr b="1" sz="1800">
                 <a:solidFill>
                   <a:srgbClr val="1A1A1A"/>
                 </a:solidFill>
@@ -14356,7 +15007,7 @@
               <a:t>Match with lab results - </a:t>
             </a:r>
             <a:r>
-              <a:rPr sz="1900">
+              <a:rPr sz="1800">
                 <a:solidFill>
                   <a:srgbClr val="1A1A1A"/>
                 </a:solidFill>
@@ -14368,13 +15019,13 @@
           <a:p>
             <a:pPr marL="292608" indent="-256032">
               <a:spcAft>
-                <a:spcPts val="600"/>
+                <a:spcPts val="400"/>
               </a:spcAft>
               <a:buFont typeface="Arial"/>
               <a:buChar char="•"/>
             </a:pPr>
             <a:r>
-              <a:rPr b="1" sz="1900">
+              <a:rPr b="1" sz="1800">
                 <a:solidFill>
                   <a:srgbClr val="1A1A1A"/>
                 </a:solidFill>
@@ -14383,13 +15034,40 @@
               <a:t>Hindi + regional languages - </a:t>
             </a:r>
             <a:r>
-              <a:rPr sz="1900">
+              <a:rPr sz="1800">
                 <a:solidFill>
                   <a:srgbClr val="1A1A1A"/>
                 </a:solidFill>
                 <a:latin typeface="Calibri"/>
               </a:rPr>
               <a:t>with voice help</a:t>
+            </a:r>
+          </a:p>
+          <a:p>
+            <a:pPr marL="292608" indent="-256032">
+              <a:spcAft>
+                <a:spcPts val="400"/>
+              </a:spcAft>
+              <a:buFont typeface="Arial"/>
+              <a:buChar char="•"/>
+            </a:pPr>
+            <a:r>
+              <a:rPr b="1" sz="1800">
+                <a:solidFill>
+                  <a:srgbClr val="1A1A1A"/>
+                </a:solidFill>
+                <a:latin typeface="Calibri"/>
+              </a:rPr>
+              <a:t>Card on the kit pouch - </a:t>
+            </a:r>
+            <a:r>
+              <a:rPr sz="1800">
+                <a:solidFill>
+                  <a:srgbClr val="1A1A1A"/>
+                </a:solidFill>
+                <a:latin typeface="Calibri"/>
+              </a:rPr>
+              <a:t>no loose card to carry</a:t>
             </a:r>
           </a:p>
         </p:txBody>
@@ -14651,360 +15329,6 @@
           </a:blipFill>
         </p:spPr>
       </p:sp>
-      <p:graphicFrame>
-        <p:nvGraphicFramePr>
-          <p:cNvPr name="Table 9" id="9"/>
-          <p:cNvGraphicFramePr>
-            <a:graphicFrameLocks noGrp="true"/>
-          </p:cNvGraphicFramePr>
-          <p:nvPr/>
-        </p:nvGraphicFramePr>
-        <p:xfrm>
-          <a:off x="12443239" y="1783080"/>
-          <a:ext cx="4816061" cy="4692661"/>
-        </p:xfrm>
-        <a:graphic>
-          <a:graphicData uri="http://schemas.openxmlformats.org/drawingml/2006/table">
-            <a:tbl>
-              <a:tblPr/>
-              <a:tblGrid>
-                <a:gridCol w="4816061"/>
-              </a:tblGrid>
-              <a:tr h="744461">
-                <a:tc>
-                  <a:txBody>
-                    <a:bodyPr anchor="t" rtlCol="false"/>
-                    <a:lstStyle/>
-                    <a:p>
-                      <a:pPr algn="ctr">
-                        <a:lnSpc>
-                          <a:spcPts val="2520"/>
-                        </a:lnSpc>
-                        <a:defRPr/>
-                      </a:pPr>
-                      <a:r>
-                        <a:rPr lang="en-US" sz="1800" b="true">
-                          <a:solidFill>
-                            <a:srgbClr val="000000"/>
-                          </a:solidFill>
-                          <a:latin typeface="Canva Sans Bold"/>
-                          <a:ea typeface="Canva Sans Bold"/>
-                          <a:cs typeface="Canva Sans Bold"/>
-                          <a:sym typeface="Canva Sans Bold"/>
-                        </a:rPr>
-                        <a:t>Official Sources</a:t>
-                      </a:r>
-                      <a:endParaRPr lang="en-US" sz="1100"/>
-                    </a:p>
-                  </a:txBody>
-                  <a:tcPr marL="190500" marR="190500" marT="190500" marB="190500" anchor="ctr">
-                    <a:lnL cmpd="sng" algn="ctr" cap="flat" w="9525">
-                      <a:solidFill>
-                        <a:srgbClr val="17375E"/>
-                      </a:solidFill>
-                      <a:prstDash val="solid"/>
-                      <a:round/>
-                      <a:headEnd type="none" w="med" len="med"/>
-                      <a:tailEnd type="none" w="med" len="med"/>
-                    </a:lnL>
-                    <a:lnR cmpd="sng" algn="ctr" cap="flat" w="9525">
-                      <a:solidFill>
-                        <a:srgbClr val="17375E"/>
-                      </a:solidFill>
-                      <a:prstDash val="solid"/>
-                      <a:round/>
-                      <a:headEnd type="none" w="med" len="med"/>
-                      <a:tailEnd type="none" w="med" len="med"/>
-                    </a:lnR>
-                    <a:lnT cmpd="sng" algn="ctr" cap="flat" w="9525">
-                      <a:solidFill>
-                        <a:srgbClr val="17375E"/>
-                      </a:solidFill>
-                      <a:prstDash val="solid"/>
-                      <a:round/>
-                      <a:headEnd type="none" w="med" len="med"/>
-                      <a:tailEnd type="none" w="med" len="med"/>
-                    </a:lnT>
-                    <a:lnB cmpd="sng" algn="ctr" cap="flat" w="9525">
-                      <a:solidFill>
-                        <a:srgbClr val="17375E"/>
-                      </a:solidFill>
-                      <a:prstDash val="solid"/>
-                      <a:round/>
-                      <a:headEnd type="none" w="med" len="med"/>
-                      <a:tailEnd type="none" w="med" len="med"/>
-                    </a:lnB>
-                    <a:solidFill>
-                      <a:srgbClr val="D0D6E8"/>
-                    </a:solidFill>
-                  </a:tcPr>
-                </a:tc>
-              </a:tr>
-              <a:tr h="1317123">
-                <a:tc>
-                  <a:txBody>
-                    <a:bodyPr anchor="t" rtlCol="false"/>
-                    <a:lstStyle/>
-                    <a:p>
-                      <a:pPr algn="ctr">
-                        <a:lnSpc>
-                          <a:spcPts val="2380"/>
-                        </a:lnSpc>
-                        <a:defRPr/>
-                      </a:pPr>
-                      <a:r>
-                        <a:rPr lang="en-US" sz="1700">
-                          <a:solidFill>
-                            <a:srgbClr val="000000"/>
-                          </a:solidFill>
-                          <a:latin typeface="Canva Sans"/>
-                          <a:ea typeface="Canva Sans"/>
-                          <a:cs typeface="Canva Sans"/>
-                          <a:sym typeface="Canva Sans"/>
-                        </a:rPr>
-                        <a:t>NDPS Act (drug law) &amp; Sampling Rules 2022</a:t>
-                      </a:r>
-                      <a:endParaRPr lang="en-US" sz="1100"/>
-                    </a:p>
-                    <a:p>
-                      <a:pPr algn="ctr">
-                        <a:lnSpc>
-                          <a:spcPts val="2380"/>
-                        </a:lnSpc>
-                      </a:pPr>
-                      <a:r>
-                        <a:rPr lang="en-US" sz="1700" u="sng">
-                          <a:solidFill>
-                            <a:srgbClr val="006EC0"/>
-                          </a:solidFill>
-                          <a:latin typeface="Canva Sans"/>
-                          <a:ea typeface="Canva Sans"/>
-                          <a:cs typeface="Canva Sans"/>
-                          <a:sym typeface="Canva Sans"/>
-                          <a:hlinkClick r:id="rId6"/>
-                        </a:rPr>
-                        <a:t>https://www.indiacode.nic.in/handle/123456789/1791</a:t>
-                      </a:r>
-                    </a:p>
-                  </a:txBody>
-                  <a:tcPr marL="190500" marR="190500" marT="190500" marB="190500" anchor="ctr">
-                    <a:lnL cmpd="sng" algn="ctr" cap="flat" w="9525">
-                      <a:solidFill>
-                        <a:srgbClr val="17375E"/>
-                      </a:solidFill>
-                      <a:prstDash val="solid"/>
-                      <a:round/>
-                      <a:headEnd type="none" w="med" len="med"/>
-                      <a:tailEnd type="none" w="med" len="med"/>
-                    </a:lnL>
-                    <a:lnR cmpd="sng" algn="ctr" cap="flat" w="9525">
-                      <a:solidFill>
-                        <a:srgbClr val="17375E"/>
-                      </a:solidFill>
-                      <a:prstDash val="solid"/>
-                      <a:round/>
-                      <a:headEnd type="none" w="med" len="med"/>
-                      <a:tailEnd type="none" w="med" len="med"/>
-                    </a:lnR>
-                    <a:lnT cmpd="sng" algn="ctr" cap="flat" w="9525">
-                      <a:solidFill>
-                        <a:srgbClr val="17375E"/>
-                      </a:solidFill>
-                      <a:prstDash val="solid"/>
-                      <a:round/>
-                      <a:headEnd type="none" w="med" len="med"/>
-                      <a:tailEnd type="none" w="med" len="med"/>
-                    </a:lnT>
-                    <a:lnB cmpd="sng" algn="ctr" cap="flat" w="9525">
-                      <a:solidFill>
-                        <a:srgbClr val="17375E"/>
-                      </a:solidFill>
-                      <a:prstDash val="solid"/>
-                      <a:round/>
-                      <a:headEnd type="none" w="med" len="med"/>
-                      <a:tailEnd type="none" w="med" len="med"/>
-                    </a:lnB>
-                  </a:tcPr>
-                </a:tc>
-              </a:tr>
-              <a:tr h="1317123">
-                <a:tc>
-                  <a:txBody>
-                    <a:bodyPr anchor="t" rtlCol="false"/>
-                    <a:lstStyle/>
-                    <a:p>
-                      <a:pPr algn="ctr">
-                        <a:lnSpc>
-                          <a:spcPts val="2380"/>
-                        </a:lnSpc>
-                        <a:defRPr/>
-                      </a:pPr>
-                      <a:r>
-                        <a:rPr lang="en-US" sz="1700">
-                          <a:solidFill>
-                            <a:srgbClr val="000000"/>
-                          </a:solidFill>
-                          <a:latin typeface="Canva Sans"/>
-                          <a:ea typeface="Canva Sans"/>
-                          <a:cs typeface="Canva Sans"/>
-                          <a:sym typeface="Canva Sans"/>
-                        </a:rPr>
-                        <a:t>NCB Field Officers' Handbook</a:t>
-                      </a:r>
-                      <a:endParaRPr lang="en-US" sz="1100"/>
-                    </a:p>
-                    <a:p>
-                      <a:pPr algn="ctr">
-                        <a:lnSpc>
-                          <a:spcPts val="2380"/>
-                        </a:lnSpc>
-                      </a:pPr>
-                      <a:r>
-                        <a:rPr lang="en-US" sz="1700" u="sng">
-                          <a:solidFill>
-                            <a:srgbClr val="006EC0"/>
-                          </a:solidFill>
-                          <a:latin typeface="Canva Sans"/>
-                          <a:ea typeface="Canva Sans"/>
-                          <a:cs typeface="Canva Sans"/>
-                          <a:sym typeface="Canva Sans"/>
-                          <a:hlinkClick r:id="rId7"/>
-                        </a:rPr>
-                        <a:t>https://narcoticsindia.nic.in/DLEA/1.pdf</a:t>
-                      </a:r>
-                    </a:p>
-                  </a:txBody>
-                  <a:tcPr marL="190500" marR="190500" marT="190500" marB="190500" anchor="ctr">
-                    <a:lnL cmpd="sng" algn="ctr" cap="flat" w="9525">
-                      <a:solidFill>
-                        <a:srgbClr val="17375E"/>
-                      </a:solidFill>
-                      <a:prstDash val="solid"/>
-                      <a:round/>
-                      <a:headEnd type="none" w="med" len="med"/>
-                      <a:tailEnd type="none" w="med" len="med"/>
-                    </a:lnL>
-                    <a:lnR cmpd="sng" algn="ctr" cap="flat" w="9525">
-                      <a:solidFill>
-                        <a:srgbClr val="17375E"/>
-                      </a:solidFill>
-                      <a:prstDash val="solid"/>
-                      <a:round/>
-                      <a:headEnd type="none" w="med" len="med"/>
-                      <a:tailEnd type="none" w="med" len="med"/>
-                    </a:lnR>
-                    <a:lnT cmpd="sng" algn="ctr" cap="flat" w="9525">
-                      <a:solidFill>
-                        <a:srgbClr val="17375E"/>
-                      </a:solidFill>
-                      <a:prstDash val="solid"/>
-                      <a:round/>
-                      <a:headEnd type="none" w="med" len="med"/>
-                      <a:tailEnd type="none" w="med" len="med"/>
-                    </a:lnT>
-                    <a:lnB cmpd="sng" algn="ctr" cap="flat" w="9525">
-                      <a:solidFill>
-                        <a:srgbClr val="17375E"/>
-                      </a:solidFill>
-                      <a:prstDash val="solid"/>
-                      <a:round/>
-                      <a:headEnd type="none" w="med" len="med"/>
-                      <a:tailEnd type="none" w="med" len="med"/>
-                    </a:lnB>
-                  </a:tcPr>
-                </a:tc>
-              </a:tr>
-              <a:tr h="1313953">
-                <a:tc>
-                  <a:txBody>
-                    <a:bodyPr anchor="t" rtlCol="false"/>
-                    <a:lstStyle/>
-                    <a:p>
-                      <a:pPr algn="ctr">
-                        <a:lnSpc>
-                          <a:spcPts val="2379"/>
-                        </a:lnSpc>
-                        <a:defRPr/>
-                      </a:pPr>
-                      <a:r>
-                        <a:rPr lang="en-US" sz="1699">
-                          <a:solidFill>
-                            <a:srgbClr val="000000"/>
-                          </a:solidFill>
-                          <a:latin typeface="Canva Sans"/>
-                          <a:ea typeface="Canva Sans"/>
-                          <a:cs typeface="Canva Sans"/>
-                          <a:sym typeface="Canva Sans"/>
-                        </a:rPr>
-                        <a:t>UNODC Drug Field-Testing Manual</a:t>
-                      </a:r>
-                      <a:endParaRPr lang="en-US" sz="1100"/>
-                    </a:p>
-                    <a:p>
-                      <a:pPr algn="ctr">
-                        <a:lnSpc>
-                          <a:spcPts val="2379"/>
-                        </a:lnSpc>
-                      </a:pPr>
-                      <a:r>
-                        <a:rPr lang="en-US" sz="1699" u="sng">
-                          <a:solidFill>
-                            <a:srgbClr val="006EC0"/>
-                          </a:solidFill>
-                          <a:latin typeface="Canva Sans"/>
-                          <a:ea typeface="Canva Sans"/>
-                          <a:cs typeface="Canva Sans"/>
-                          <a:sym typeface="Canva Sans"/>
-                          <a:hlinkClick r:id="rId8"/>
-                        </a:rPr>
-                        <a:t>https://www.unodc.org/documents/scientific/Rapid_Testing_Methods_of_Drugs_of_Abuse_E.pdf</a:t>
-                      </a:r>
-                    </a:p>
-                  </a:txBody>
-                  <a:tcPr marL="190500" marR="190500" marT="190500" marB="190500" anchor="ctr">
-                    <a:lnL cmpd="sng" algn="ctr" cap="flat" w="9525">
-                      <a:solidFill>
-                        <a:srgbClr val="17375E"/>
-                      </a:solidFill>
-                      <a:prstDash val="solid"/>
-                      <a:round/>
-                      <a:headEnd type="none" w="med" len="med"/>
-                      <a:tailEnd type="none" w="med" len="med"/>
-                    </a:lnL>
-                    <a:lnR cmpd="sng" algn="ctr" cap="flat" w="9525">
-                      <a:solidFill>
-                        <a:srgbClr val="17375E"/>
-                      </a:solidFill>
-                      <a:prstDash val="solid"/>
-                      <a:round/>
-                      <a:headEnd type="none" w="med" len="med"/>
-                      <a:tailEnd type="none" w="med" len="med"/>
-                    </a:lnR>
-                    <a:lnT cmpd="sng" algn="ctr" cap="flat" w="9525">
-                      <a:solidFill>
-                        <a:srgbClr val="17375E"/>
-                      </a:solidFill>
-                      <a:prstDash val="solid"/>
-                      <a:round/>
-                      <a:headEnd type="none" w="med" len="med"/>
-                      <a:tailEnd type="none" w="med" len="med"/>
-                    </a:lnT>
-                    <a:lnB cmpd="sng" algn="ctr" cap="flat" w="9525">
-                      <a:solidFill>
-                        <a:srgbClr val="17375E"/>
-                      </a:solidFill>
-                      <a:prstDash val="solid"/>
-                      <a:round/>
-                      <a:headEnd type="none" w="med" len="med"/>
-                      <a:tailEnd type="none" w="med" len="med"/>
-                    </a:lnB>
-                  </a:tcPr>
-                </a:tc>
-              </a:tr>
-            </a:tbl>
-          </a:graphicData>
-        </a:graphic>
-      </p:graphicFrame>
       <p:sp>
         <p:nvSpPr>
           <p:cNvPr name="TextBox 10" id="10" descr="$PPTXTitle"/>
@@ -15136,7 +15460,7 @@
         </p:nvSpPr>
         <p:spPr>
           <a:xfrm rot="0">
-            <a:off x="8412480" y="8503919"/>
+            <a:off x="8412480" y="8183879"/>
             <a:ext cx="8229600" cy="381000"/>
           </a:xfrm>
           <a:prstGeom prst="rect">
@@ -15218,7 +15542,7 @@
         </p:nvSpPr>
         <p:spPr>
           <a:xfrm rot="0">
-            <a:off x="914400" y="8503919"/>
+            <a:off x="914400" y="8183879"/>
             <a:ext cx="3931920" cy="390525"/>
           </a:xfrm>
           <a:prstGeom prst="rect">
@@ -15274,7 +15598,7 @@
         </p:nvSpPr>
         <p:spPr>
           <a:xfrm rot="0">
-            <a:off x="4754880" y="8503919"/>
+            <a:off x="4754880" y="8183879"/>
             <a:ext cx="3200400" cy="361950"/>
           </a:xfrm>
           <a:prstGeom prst="rect">
@@ -15318,7 +15642,7 @@
         </p:nvGraphicFramePr>
         <p:xfrm>
           <a:off x="777240" y="1783080"/>
-          <a:ext cx="11384280" cy="6537960"/>
+          <a:ext cx="11384280" cy="5833872"/>
         </p:xfrm>
         <a:graphic>
           <a:graphicData uri="http://schemas.openxmlformats.org/drawingml/2006/table">
@@ -15426,7 +15750,7 @@
                   </a:tcPr>
                 </a:tc>
               </a:tr>
-              <a:tr h="868680">
+              <a:tr h="768096">
                 <a:tc>
                   <a:txBody>
                     <a:bodyPr wrap="square"/>
@@ -15533,7 +15857,7 @@
                   </a:tcPr>
                 </a:tc>
               </a:tr>
-              <a:tr h="868680">
+              <a:tr h="768096">
                 <a:tc>
                   <a:txBody>
                     <a:bodyPr wrap="square"/>
@@ -15640,7 +15964,7 @@
                   </a:tcPr>
                 </a:tc>
               </a:tr>
-              <a:tr h="868680">
+              <a:tr h="768096">
                 <a:tc>
                   <a:txBody>
                     <a:bodyPr wrap="square"/>
@@ -15747,7 +16071,7 @@
                   </a:tcPr>
                 </a:tc>
               </a:tr>
-              <a:tr h="868680">
+              <a:tr h="768096">
                 <a:tc>
                   <a:txBody>
                     <a:bodyPr wrap="square"/>
@@ -15854,7 +16178,7 @@
                   </a:tcPr>
                 </a:tc>
               </a:tr>
-              <a:tr h="868680">
+              <a:tr h="768096">
                 <a:tc>
                   <a:txBody>
                     <a:bodyPr wrap="square"/>
@@ -15961,7 +16285,7 @@
                   </a:tcPr>
                 </a:tc>
               </a:tr>
-              <a:tr h="868680">
+              <a:tr h="768096">
                 <a:tc>
                   <a:txBody>
                     <a:bodyPr wrap="square"/>
@@ -16068,7 +16392,7 @@
                   </a:tcPr>
                 </a:tc>
               </a:tr>
-              <a:tr h="868680">
+              <a:tr h="768096">
                 <a:tc>
                   <a:txBody>
                     <a:bodyPr wrap="square"/>
@@ -16179,6 +16503,1097 @@
           </a:graphicData>
         </a:graphic>
       </p:graphicFrame>
+      <p:sp>
+        <p:nvSpPr>
+          <p:cNvPr id="18" name="TextBox 17"/>
+          <p:cNvSpPr txBox="1"/>
+          <p:nvPr/>
+        </p:nvSpPr>
+        <p:spPr>
+          <a:xfrm>
+            <a:off x="822960" y="7708392"/>
+            <a:ext cx="11338560" cy="365760"/>
+          </a:xfrm>
+          <a:prstGeom prst="rect">
+            <a:avLst/>
+          </a:prstGeom>
+          <a:noFill/>
+        </p:spPr>
+        <p:txBody>
+          <a:bodyPr wrap="none">
+            <a:spAutoFit/>
+          </a:bodyPr>
+          <a:lstStyle/>
+          <a:p>
+            <a:r>
+              <a:rPr b="1" sz="1300">
+                <a:solidFill>
+                  <a:srgbClr val="1F3864"/>
+                </a:solidFill>
+                <a:latin typeface="Calibri"/>
+              </a:rPr>
+              <a:t>Official sources:  </a:t>
+            </a:r>
+            <a:r>
+              <a:rPr sz="1300" u="sng">
+                <a:solidFill>
+                  <a:srgbClr val="0563C1"/>
+                </a:solidFill>
+                <a:latin typeface="Calibri"/>
+                <a:hlinkClick r:id="rId19"/>
+              </a:rPr>
+              <a:t>NDPS Act &amp; Sampling Rules 2022</a:t>
+            </a:r>
+            <a:r>
+              <a:rPr sz="1300">
+                <a:latin typeface="Calibri"/>
+              </a:rPr>
+              <a:t>   ·   </a:t>
+            </a:r>
+            <a:r>
+              <a:rPr sz="1300" u="sng">
+                <a:solidFill>
+                  <a:srgbClr val="0563C1"/>
+                </a:solidFill>
+                <a:latin typeface="Calibri"/>
+                <a:hlinkClick r:id="rId20"/>
+              </a:rPr>
+              <a:t>NCB Field Officers' Handbook</a:t>
+            </a:r>
+            <a:r>
+              <a:rPr sz="1300">
+                <a:latin typeface="Calibri"/>
+              </a:rPr>
+              <a:t>   ·   </a:t>
+            </a:r>
+            <a:r>
+              <a:rPr sz="1300" u="sng">
+                <a:solidFill>
+                  <a:srgbClr val="0563C1"/>
+                </a:solidFill>
+                <a:latin typeface="Calibri"/>
+                <a:hlinkClick r:id="rId21"/>
+              </a:rPr>
+              <a:t>UNODC Drug Field-Testing Manual</a:t>
+            </a:r>
+            <a:r>
+              <a:rPr sz="1300">
+                <a:latin typeface="Calibri"/>
+              </a:rPr>
+              <a:t>   ·   </a:t>
+            </a:r>
+            <a:r>
+              <a:rPr sz="1300" u="sng">
+                <a:solidFill>
+                  <a:srgbClr val="0563C1"/>
+                </a:solidFill>
+                <a:latin typeface="Calibri"/>
+                <a:hlinkClick r:id="rId22"/>
+              </a:rPr>
+              <a:t>BNSS / BSA 2023 (MHA)</a:t>
+            </a:r>
+          </a:p>
+        </p:txBody>
+      </p:sp>
+      <p:sp>
+        <p:nvSpPr>
+          <p:cNvPr id="19" name="TextBox 18"/>
+          <p:cNvSpPr txBox="1"/>
+          <p:nvPr/>
+        </p:nvSpPr>
+        <p:spPr>
+          <a:xfrm>
+            <a:off x="12298680" y="1737360"/>
+            <a:ext cx="5486400" cy="411480"/>
+          </a:xfrm>
+          <a:prstGeom prst="rect">
+            <a:avLst/>
+          </a:prstGeom>
+          <a:noFill/>
+        </p:spPr>
+        <p:txBody>
+          <a:bodyPr wrap="square" anchor="t" lIns="45720" rIns="45720" tIns="18288" bIns="18288">
+            <a:spAutoFit/>
+          </a:bodyPr>
+          <a:lstStyle/>
+          <a:p>
+            <a:pPr algn="l"/>
+            <a:r>
+              <a:rPr sz="1800" b="1" i="0">
+                <a:solidFill>
+                  <a:srgbClr val="1F3864"/>
+                </a:solidFill>
+                <a:latin typeface="Calibri"/>
+              </a:rPr>
+              <a:t>Competitor Map - where we stand</a:t>
+            </a:r>
+          </a:p>
+        </p:txBody>
+      </p:sp>
+      <p:graphicFrame>
+        <p:nvGraphicFramePr>
+          <p:cNvPr id="20" name="Table 19"/>
+          <p:cNvGraphicFramePr>
+            <a:graphicFrameLocks noGrp="1"/>
+          </p:cNvGraphicFramePr>
+          <p:nvPr/>
+        </p:nvGraphicFramePr>
+        <p:xfrm>
+          <a:off x="12298680" y="2194560"/>
+          <a:ext cx="5404104" cy="3401568"/>
+        </p:xfrm>
+        <a:graphic>
+          <a:graphicData uri="http://schemas.openxmlformats.org/drawingml/2006/table">
+            <a:tbl>
+              <a:tblPr firstRow="1">
+                <a:tableStyleId>{5940675A-B579-460E-94D1-54222C63F5DA}</a:tableStyleId>
+              </a:tblPr>
+              <a:tblGrid>
+                <a:gridCol w="1783080"/>
+                <a:gridCol w="905256"/>
+                <a:gridCol w="905256"/>
+                <a:gridCol w="905256"/>
+                <a:gridCol w="905256"/>
+              </a:tblGrid>
+              <a:tr h="658368">
+                <a:tc>
+                  <a:txBody>
+                    <a:bodyPr wrap="square"/>
+                    <a:lstStyle/>
+                    <a:p>
+                      <a:pPr algn="l"/>
+                      <a:r>
+                        <a:rPr sz="1050" b="1">
+                          <a:solidFill>
+                            <a:srgbClr val="1F3864"/>
+                          </a:solidFill>
+                          <a:latin typeface="Calibri"/>
+                        </a:rPr>
+                        <a:t>Option</a:t>
+                      </a:r>
+                    </a:p>
+                  </a:txBody>
+                  <a:tcPr anchor="ctr" marL="64008" marR="64008" marT="27432" marB="27432">
+                    <a:solidFill>
+                      <a:srgbClr val="CFD5EA"/>
+                    </a:solidFill>
+                  </a:tcPr>
+                </a:tc>
+                <a:tc>
+                  <a:txBody>
+                    <a:bodyPr wrap="square"/>
+                    <a:lstStyle/>
+                    <a:p>
+                      <a:pPr algn="ctr"/>
+                      <a:r>
+                        <a:rPr sz="1050" b="1">
+                          <a:solidFill>
+                            <a:srgbClr val="1F3864"/>
+                          </a:solidFill>
+                          <a:latin typeface="Calibri"/>
+                        </a:rPr>
+                        <a:t>Works with existing kits</a:t>
+                      </a:r>
+                    </a:p>
+                  </a:txBody>
+                  <a:tcPr anchor="ctr" marL="64008" marR="64008" marT="27432" marB="27432">
+                    <a:solidFill>
+                      <a:srgbClr val="CFD5EA"/>
+                    </a:solidFill>
+                  </a:tcPr>
+                </a:tc>
+                <a:tc>
+                  <a:txBody>
+                    <a:bodyPr wrap="square"/>
+                    <a:lstStyle/>
+                    <a:p>
+                      <a:pPr algn="ctr"/>
+                      <a:r>
+                        <a:rPr sz="1050" b="1">
+                          <a:solidFill>
+                            <a:srgbClr val="1F3864"/>
+                          </a:solidFill>
+                          <a:latin typeface="Calibri"/>
+                        </a:rPr>
+                        <a:t>No new hardware</a:t>
+                      </a:r>
+                    </a:p>
+                  </a:txBody>
+                  <a:tcPr anchor="ctr" marL="64008" marR="64008" marT="27432" marB="27432">
+                    <a:solidFill>
+                      <a:srgbClr val="CFD5EA"/>
+                    </a:solidFill>
+                  </a:tcPr>
+                </a:tc>
+                <a:tc>
+                  <a:txBody>
+                    <a:bodyPr wrap="square"/>
+                    <a:lstStyle/>
+                    <a:p>
+                      <a:pPr algn="ctr"/>
+                      <a:r>
+                        <a:rPr sz="1050" b="1">
+                          <a:solidFill>
+                            <a:srgbClr val="1F3864"/>
+                          </a:solidFill>
+                          <a:latin typeface="Calibri"/>
+                        </a:rPr>
+                        <a:t>Objective reading</a:t>
+                      </a:r>
+                    </a:p>
+                  </a:txBody>
+                  <a:tcPr anchor="ctr" marL="64008" marR="64008" marT="27432" marB="27432">
+                    <a:solidFill>
+                      <a:srgbClr val="CFD5EA"/>
+                    </a:solidFill>
+                  </a:tcPr>
+                </a:tc>
+                <a:tc>
+                  <a:txBody>
+                    <a:bodyPr wrap="square"/>
+                    <a:lstStyle/>
+                    <a:p>
+                      <a:pPr algn="ctr"/>
+                      <a:r>
+                        <a:rPr sz="1050" b="1">
+                          <a:solidFill>
+                            <a:srgbClr val="1F3864"/>
+                          </a:solidFill>
+                          <a:latin typeface="Calibri"/>
+                        </a:rPr>
+                        <a:t>Signed proof</a:t>
+                      </a:r>
+                    </a:p>
+                  </a:txBody>
+                  <a:tcPr anchor="ctr" marL="64008" marR="64008" marT="27432" marB="27432">
+                    <a:solidFill>
+                      <a:srgbClr val="CFD5EA"/>
+                    </a:solidFill>
+                  </a:tcPr>
+                </a:tc>
+              </a:tr>
+              <a:tr h="457200">
+                <a:tc>
+                  <a:txBody>
+                    <a:bodyPr wrap="square"/>
+                    <a:lstStyle/>
+                    <a:p>
+                      <a:pPr algn="l"/>
+                      <a:r>
+                        <a:rPr sz="1150" b="0">
+                          <a:solidFill>
+                            <a:srgbClr val="1A1A1A"/>
+                          </a:solidFill>
+                          <a:latin typeface="Calibri"/>
+                        </a:rPr>
+                        <a:t>Officer's eye (today)</a:t>
+                      </a:r>
+                    </a:p>
+                  </a:txBody>
+                  <a:tcPr anchor="ctr" marL="64008" marR="64008" marT="27432" marB="27432">
+                    <a:solidFill>
+                      <a:srgbClr val="FFFFFF"/>
+                    </a:solidFill>
+                  </a:tcPr>
+                </a:tc>
+                <a:tc>
+                  <a:txBody>
+                    <a:bodyPr wrap="square"/>
+                    <a:lstStyle/>
+                    <a:p>
+                      <a:pPr algn="ctr"/>
+                      <a:r>
+                        <a:rPr sz="1600" b="1">
+                          <a:solidFill>
+                            <a:srgbClr val="2E7D32"/>
+                          </a:solidFill>
+                          <a:latin typeface="Calibri"/>
+                        </a:rPr>
+                        <a:t>✓</a:t>
+                      </a:r>
+                    </a:p>
+                  </a:txBody>
+                  <a:tcPr anchor="ctr" marL="64008" marR="64008" marT="27432" marB="27432">
+                    <a:solidFill>
+                      <a:srgbClr val="FFFFFF"/>
+                    </a:solidFill>
+                  </a:tcPr>
+                </a:tc>
+                <a:tc>
+                  <a:txBody>
+                    <a:bodyPr wrap="square"/>
+                    <a:lstStyle/>
+                    <a:p>
+                      <a:pPr algn="ctr"/>
+                      <a:r>
+                        <a:rPr sz="1600" b="1">
+                          <a:solidFill>
+                            <a:srgbClr val="2E7D32"/>
+                          </a:solidFill>
+                          <a:latin typeface="Calibri"/>
+                        </a:rPr>
+                        <a:t>✓</a:t>
+                      </a:r>
+                    </a:p>
+                  </a:txBody>
+                  <a:tcPr anchor="ctr" marL="64008" marR="64008" marT="27432" marB="27432">
+                    <a:solidFill>
+                      <a:srgbClr val="FFFFFF"/>
+                    </a:solidFill>
+                  </a:tcPr>
+                </a:tc>
+                <a:tc>
+                  <a:txBody>
+                    <a:bodyPr wrap="square"/>
+                    <a:lstStyle/>
+                    <a:p>
+                      <a:pPr algn="ctr"/>
+                      <a:r>
+                        <a:rPr sz="1600" b="1">
+                          <a:solidFill>
+                            <a:srgbClr val="C62828"/>
+                          </a:solidFill>
+                          <a:latin typeface="Calibri"/>
+                        </a:rPr>
+                        <a:t>✗</a:t>
+                      </a:r>
+                    </a:p>
+                  </a:txBody>
+                  <a:tcPr anchor="ctr" marL="64008" marR="64008" marT="27432" marB="27432">
+                    <a:solidFill>
+                      <a:srgbClr val="FFFFFF"/>
+                    </a:solidFill>
+                  </a:tcPr>
+                </a:tc>
+                <a:tc>
+                  <a:txBody>
+                    <a:bodyPr wrap="square"/>
+                    <a:lstStyle/>
+                    <a:p>
+                      <a:pPr algn="ctr"/>
+                      <a:r>
+                        <a:rPr sz="1600" b="1">
+                          <a:solidFill>
+                            <a:srgbClr val="C62828"/>
+                          </a:solidFill>
+                          <a:latin typeface="Calibri"/>
+                        </a:rPr>
+                        <a:t>✗</a:t>
+                      </a:r>
+                    </a:p>
+                  </a:txBody>
+                  <a:tcPr anchor="ctr" marL="64008" marR="64008" marT="27432" marB="27432">
+                    <a:solidFill>
+                      <a:srgbClr val="FFFFFF"/>
+                    </a:solidFill>
+                  </a:tcPr>
+                </a:tc>
+              </a:tr>
+              <a:tr h="457200">
+                <a:tc>
+                  <a:txBody>
+                    <a:bodyPr wrap="square"/>
+                    <a:lstStyle/>
+                    <a:p>
+                      <a:pPr algn="l"/>
+                      <a:r>
+                        <a:rPr sz="1150" b="0">
+                          <a:solidFill>
+                            <a:srgbClr val="1A1A1A"/>
+                          </a:solidFill>
+                          <a:latin typeface="Calibri"/>
+                        </a:rPr>
+                        <a:t>DetectaChem app (USA)</a:t>
+                      </a:r>
+                    </a:p>
+                  </a:txBody>
+                  <a:tcPr anchor="ctr" marL="64008" marR="64008" marT="27432" marB="27432">
+                    <a:solidFill>
+                      <a:srgbClr val="F4F6FB"/>
+                    </a:solidFill>
+                  </a:tcPr>
+                </a:tc>
+                <a:tc>
+                  <a:txBody>
+                    <a:bodyPr wrap="square"/>
+                    <a:lstStyle/>
+                    <a:p>
+                      <a:pPr algn="ctr"/>
+                      <a:r>
+                        <a:rPr sz="1600" b="1">
+                          <a:solidFill>
+                            <a:srgbClr val="C62828"/>
+                          </a:solidFill>
+                          <a:latin typeface="Calibri"/>
+                        </a:rPr>
+                        <a:t>✗</a:t>
+                      </a:r>
+                    </a:p>
+                  </a:txBody>
+                  <a:tcPr anchor="ctr" marL="64008" marR="64008" marT="27432" marB="27432">
+                    <a:solidFill>
+                      <a:srgbClr val="F4F6FB"/>
+                    </a:solidFill>
+                  </a:tcPr>
+                </a:tc>
+                <a:tc>
+                  <a:txBody>
+                    <a:bodyPr wrap="square"/>
+                    <a:lstStyle/>
+                    <a:p>
+                      <a:pPr algn="ctr"/>
+                      <a:r>
+                        <a:rPr sz="1600" b="1">
+                          <a:solidFill>
+                            <a:srgbClr val="2E7D32"/>
+                          </a:solidFill>
+                          <a:latin typeface="Calibri"/>
+                        </a:rPr>
+                        <a:t>✓</a:t>
+                      </a:r>
+                    </a:p>
+                  </a:txBody>
+                  <a:tcPr anchor="ctr" marL="64008" marR="64008" marT="27432" marB="27432">
+                    <a:solidFill>
+                      <a:srgbClr val="F4F6FB"/>
+                    </a:solidFill>
+                  </a:tcPr>
+                </a:tc>
+                <a:tc>
+                  <a:txBody>
+                    <a:bodyPr wrap="square"/>
+                    <a:lstStyle/>
+                    <a:p>
+                      <a:pPr algn="ctr"/>
+                      <a:r>
+                        <a:rPr sz="1600" b="1">
+                          <a:solidFill>
+                            <a:srgbClr val="2E7D32"/>
+                          </a:solidFill>
+                          <a:latin typeface="Calibri"/>
+                        </a:rPr>
+                        <a:t>✓</a:t>
+                      </a:r>
+                    </a:p>
+                  </a:txBody>
+                  <a:tcPr anchor="ctr" marL="64008" marR="64008" marT="27432" marB="27432">
+                    <a:solidFill>
+                      <a:srgbClr val="F4F6FB"/>
+                    </a:solidFill>
+                  </a:tcPr>
+                </a:tc>
+                <a:tc>
+                  <a:txBody>
+                    <a:bodyPr wrap="square"/>
+                    <a:lstStyle/>
+                    <a:p>
+                      <a:pPr algn="ctr"/>
+                      <a:r>
+                        <a:rPr sz="1600" b="1">
+                          <a:solidFill>
+                            <a:srgbClr val="B26A00"/>
+                          </a:solidFill>
+                          <a:latin typeface="Calibri"/>
+                        </a:rPr>
+                        <a:t>~</a:t>
+                      </a:r>
+                    </a:p>
+                  </a:txBody>
+                  <a:tcPr anchor="ctr" marL="64008" marR="64008" marT="27432" marB="27432">
+                    <a:solidFill>
+                      <a:srgbClr val="F4F6FB"/>
+                    </a:solidFill>
+                  </a:tcPr>
+                </a:tc>
+              </a:tr>
+              <a:tr h="457200">
+                <a:tc>
+                  <a:txBody>
+                    <a:bodyPr wrap="square"/>
+                    <a:lstStyle/>
+                    <a:p>
+                      <a:pPr algn="l"/>
+                      <a:r>
+                        <a:rPr sz="1150" b="0">
+                          <a:solidFill>
+                            <a:srgbClr val="1A1A1A"/>
+                          </a:solidFill>
+                          <a:latin typeface="Calibri"/>
+                        </a:rPr>
+                        <a:t>TruNarc / Raman device</a:t>
+                      </a:r>
+                    </a:p>
+                  </a:txBody>
+                  <a:tcPr anchor="ctr" marL="64008" marR="64008" marT="27432" marB="27432">
+                    <a:solidFill>
+                      <a:srgbClr val="FFFFFF"/>
+                    </a:solidFill>
+                  </a:tcPr>
+                </a:tc>
+                <a:tc>
+                  <a:txBody>
+                    <a:bodyPr wrap="square"/>
+                    <a:lstStyle/>
+                    <a:p>
+                      <a:pPr algn="ctr"/>
+                      <a:r>
+                        <a:rPr sz="1600" b="1">
+                          <a:solidFill>
+                            <a:srgbClr val="2E7D32"/>
+                          </a:solidFill>
+                          <a:latin typeface="Calibri"/>
+                        </a:rPr>
+                        <a:t>✓</a:t>
+                      </a:r>
+                    </a:p>
+                  </a:txBody>
+                  <a:tcPr anchor="ctr" marL="64008" marR="64008" marT="27432" marB="27432">
+                    <a:solidFill>
+                      <a:srgbClr val="FFFFFF"/>
+                    </a:solidFill>
+                  </a:tcPr>
+                </a:tc>
+                <a:tc>
+                  <a:txBody>
+                    <a:bodyPr wrap="square"/>
+                    <a:lstStyle/>
+                    <a:p>
+                      <a:pPr algn="ctr"/>
+                      <a:r>
+                        <a:rPr sz="1600" b="1">
+                          <a:solidFill>
+                            <a:srgbClr val="C62828"/>
+                          </a:solidFill>
+                          <a:latin typeface="Calibri"/>
+                        </a:rPr>
+                        <a:t>✗</a:t>
+                      </a:r>
+                    </a:p>
+                  </a:txBody>
+                  <a:tcPr anchor="ctr" marL="64008" marR="64008" marT="27432" marB="27432">
+                    <a:solidFill>
+                      <a:srgbClr val="FFFFFF"/>
+                    </a:solidFill>
+                  </a:tcPr>
+                </a:tc>
+                <a:tc>
+                  <a:txBody>
+                    <a:bodyPr wrap="square"/>
+                    <a:lstStyle/>
+                    <a:p>
+                      <a:pPr algn="ctr"/>
+                      <a:r>
+                        <a:rPr sz="1600" b="1">
+                          <a:solidFill>
+                            <a:srgbClr val="2E7D32"/>
+                          </a:solidFill>
+                          <a:latin typeface="Calibri"/>
+                        </a:rPr>
+                        <a:t>✓</a:t>
+                      </a:r>
+                    </a:p>
+                  </a:txBody>
+                  <a:tcPr anchor="ctr" marL="64008" marR="64008" marT="27432" marB="27432">
+                    <a:solidFill>
+                      <a:srgbClr val="FFFFFF"/>
+                    </a:solidFill>
+                  </a:tcPr>
+                </a:tc>
+                <a:tc>
+                  <a:txBody>
+                    <a:bodyPr wrap="square"/>
+                    <a:lstStyle/>
+                    <a:p>
+                      <a:pPr algn="ctr"/>
+                      <a:r>
+                        <a:rPr sz="1600" b="1">
+                          <a:solidFill>
+                            <a:srgbClr val="B26A00"/>
+                          </a:solidFill>
+                          <a:latin typeface="Calibri"/>
+                        </a:rPr>
+                        <a:t>~</a:t>
+                      </a:r>
+                    </a:p>
+                  </a:txBody>
+                  <a:tcPr anchor="ctr" marL="64008" marR="64008" marT="27432" marB="27432">
+                    <a:solidFill>
+                      <a:srgbClr val="FFFFFF"/>
+                    </a:solidFill>
+                  </a:tcPr>
+                </a:tc>
+              </a:tr>
+              <a:tr h="457200">
+                <a:tc>
+                  <a:txBody>
+                    <a:bodyPr wrap="square"/>
+                    <a:lstStyle/>
+                    <a:p>
+                      <a:pPr algn="l"/>
+                      <a:r>
+                        <a:rPr sz="1150" b="0">
+                          <a:solidFill>
+                            <a:srgbClr val="1A1A1A"/>
+                          </a:solidFill>
+                          <a:latin typeface="Calibri"/>
+                        </a:rPr>
+                        <a:t>e-Sakshya app (MHA)</a:t>
+                      </a:r>
+                    </a:p>
+                  </a:txBody>
+                  <a:tcPr anchor="ctr" marL="64008" marR="64008" marT="27432" marB="27432">
+                    <a:solidFill>
+                      <a:srgbClr val="F4F6FB"/>
+                    </a:solidFill>
+                  </a:tcPr>
+                </a:tc>
+                <a:tc>
+                  <a:txBody>
+                    <a:bodyPr wrap="square"/>
+                    <a:lstStyle/>
+                    <a:p>
+                      <a:pPr algn="ctr"/>
+                      <a:r>
+                        <a:rPr sz="1600" b="1">
+                          <a:solidFill>
+                            <a:srgbClr val="2E7D32"/>
+                          </a:solidFill>
+                          <a:latin typeface="Calibri"/>
+                        </a:rPr>
+                        <a:t>✓</a:t>
+                      </a:r>
+                    </a:p>
+                  </a:txBody>
+                  <a:tcPr anchor="ctr" marL="64008" marR="64008" marT="27432" marB="27432">
+                    <a:solidFill>
+                      <a:srgbClr val="F4F6FB"/>
+                    </a:solidFill>
+                  </a:tcPr>
+                </a:tc>
+                <a:tc>
+                  <a:txBody>
+                    <a:bodyPr wrap="square"/>
+                    <a:lstStyle/>
+                    <a:p>
+                      <a:pPr algn="ctr"/>
+                      <a:r>
+                        <a:rPr sz="1600" b="1">
+                          <a:solidFill>
+                            <a:srgbClr val="2E7D32"/>
+                          </a:solidFill>
+                          <a:latin typeface="Calibri"/>
+                        </a:rPr>
+                        <a:t>✓</a:t>
+                      </a:r>
+                    </a:p>
+                  </a:txBody>
+                  <a:tcPr anchor="ctr" marL="64008" marR="64008" marT="27432" marB="27432">
+                    <a:solidFill>
+                      <a:srgbClr val="F4F6FB"/>
+                    </a:solidFill>
+                  </a:tcPr>
+                </a:tc>
+                <a:tc>
+                  <a:txBody>
+                    <a:bodyPr wrap="square"/>
+                    <a:lstStyle/>
+                    <a:p>
+                      <a:pPr algn="ctr"/>
+                      <a:r>
+                        <a:rPr sz="1600" b="1">
+                          <a:solidFill>
+                            <a:srgbClr val="C62828"/>
+                          </a:solidFill>
+                          <a:latin typeface="Calibri"/>
+                        </a:rPr>
+                        <a:t>✗</a:t>
+                      </a:r>
+                    </a:p>
+                  </a:txBody>
+                  <a:tcPr anchor="ctr" marL="64008" marR="64008" marT="27432" marB="27432">
+                    <a:solidFill>
+                      <a:srgbClr val="F4F6FB"/>
+                    </a:solidFill>
+                  </a:tcPr>
+                </a:tc>
+                <a:tc>
+                  <a:txBody>
+                    <a:bodyPr wrap="square"/>
+                    <a:lstStyle/>
+                    <a:p>
+                      <a:pPr algn="ctr"/>
+                      <a:r>
+                        <a:rPr sz="1600" b="1">
+                          <a:solidFill>
+                            <a:srgbClr val="2E7D32"/>
+                          </a:solidFill>
+                          <a:latin typeface="Calibri"/>
+                        </a:rPr>
+                        <a:t>✓</a:t>
+                      </a:r>
+                    </a:p>
+                  </a:txBody>
+                  <a:tcPr anchor="ctr" marL="64008" marR="64008" marT="27432" marB="27432">
+                    <a:solidFill>
+                      <a:srgbClr val="F4F6FB"/>
+                    </a:solidFill>
+                  </a:tcPr>
+                </a:tc>
+              </a:tr>
+              <a:tr h="457200">
+                <a:tc>
+                  <a:txBody>
+                    <a:bodyPr wrap="square"/>
+                    <a:lstStyle/>
+                    <a:p>
+                      <a:pPr algn="l"/>
+                      <a:r>
+                        <a:rPr sz="1150" b="0">
+                          <a:solidFill>
+                            <a:srgbClr val="1A1A1A"/>
+                          </a:solidFill>
+                          <a:latin typeface="Calibri"/>
+                        </a:rPr>
+                        <a:t>FSL lab test (GC-MS)</a:t>
+                      </a:r>
+                    </a:p>
+                  </a:txBody>
+                  <a:tcPr anchor="ctr" marL="64008" marR="64008" marT="27432" marB="27432">
+                    <a:solidFill>
+                      <a:srgbClr val="FFFFFF"/>
+                    </a:solidFill>
+                  </a:tcPr>
+                </a:tc>
+                <a:tc>
+                  <a:txBody>
+                    <a:bodyPr wrap="square"/>
+                    <a:lstStyle/>
+                    <a:p>
+                      <a:pPr algn="ctr"/>
+                      <a:r>
+                        <a:rPr sz="1600" b="1">
+                          <a:solidFill>
+                            <a:srgbClr val="404040"/>
+                          </a:solidFill>
+                          <a:latin typeface="Calibri"/>
+                        </a:rPr>
+                        <a:t>-</a:t>
+                      </a:r>
+                    </a:p>
+                  </a:txBody>
+                  <a:tcPr anchor="ctr" marL="64008" marR="64008" marT="27432" marB="27432">
+                    <a:solidFill>
+                      <a:srgbClr val="FFFFFF"/>
+                    </a:solidFill>
+                  </a:tcPr>
+                </a:tc>
+                <a:tc>
+                  <a:txBody>
+                    <a:bodyPr wrap="square"/>
+                    <a:lstStyle/>
+                    <a:p>
+                      <a:pPr algn="ctr"/>
+                      <a:r>
+                        <a:rPr sz="1600" b="1">
+                          <a:solidFill>
+                            <a:srgbClr val="C62828"/>
+                          </a:solidFill>
+                          <a:latin typeface="Calibri"/>
+                        </a:rPr>
+                        <a:t>✗</a:t>
+                      </a:r>
+                    </a:p>
+                  </a:txBody>
+                  <a:tcPr anchor="ctr" marL="64008" marR="64008" marT="27432" marB="27432">
+                    <a:solidFill>
+                      <a:srgbClr val="FFFFFF"/>
+                    </a:solidFill>
+                  </a:tcPr>
+                </a:tc>
+                <a:tc>
+                  <a:txBody>
+                    <a:bodyPr wrap="square"/>
+                    <a:lstStyle/>
+                    <a:p>
+                      <a:pPr algn="ctr"/>
+                      <a:r>
+                        <a:rPr sz="1600" b="1">
+                          <a:solidFill>
+                            <a:srgbClr val="2E7D32"/>
+                          </a:solidFill>
+                          <a:latin typeface="Calibri"/>
+                        </a:rPr>
+                        <a:t>✓</a:t>
+                      </a:r>
+                    </a:p>
+                  </a:txBody>
+                  <a:tcPr anchor="ctr" marL="64008" marR="64008" marT="27432" marB="27432">
+                    <a:solidFill>
+                      <a:srgbClr val="FFFFFF"/>
+                    </a:solidFill>
+                  </a:tcPr>
+                </a:tc>
+                <a:tc>
+                  <a:txBody>
+                    <a:bodyPr wrap="square"/>
+                    <a:lstStyle/>
+                    <a:p>
+                      <a:pPr algn="ctr"/>
+                      <a:r>
+                        <a:rPr sz="1600" b="1">
+                          <a:solidFill>
+                            <a:srgbClr val="2E7D32"/>
+                          </a:solidFill>
+                          <a:latin typeface="Calibri"/>
+                        </a:rPr>
+                        <a:t>✓</a:t>
+                      </a:r>
+                    </a:p>
+                  </a:txBody>
+                  <a:tcPr anchor="ctr" marL="64008" marR="64008" marT="27432" marB="27432">
+                    <a:solidFill>
+                      <a:srgbClr val="FFFFFF"/>
+                    </a:solidFill>
+                  </a:tcPr>
+                </a:tc>
+              </a:tr>
+              <a:tr h="457200">
+                <a:tc>
+                  <a:txBody>
+                    <a:bodyPr wrap="square"/>
+                    <a:lstStyle/>
+                    <a:p>
+                      <a:pPr algn="l"/>
+                      <a:r>
+                        <a:rPr sz="1150" b="1">
+                          <a:solidFill>
+                            <a:srgbClr val="1F3864"/>
+                          </a:solidFill>
+                          <a:latin typeface="Calibri"/>
+                        </a:rPr>
+                        <a:t>FieldProof (ours)</a:t>
+                      </a:r>
+                    </a:p>
+                  </a:txBody>
+                  <a:tcPr anchor="ctr" marL="64008" marR="64008" marT="27432" marB="27432">
+                    <a:solidFill>
+                      <a:srgbClr val="D9F2E3"/>
+                    </a:solidFill>
+                  </a:tcPr>
+                </a:tc>
+                <a:tc>
+                  <a:txBody>
+                    <a:bodyPr wrap="square"/>
+                    <a:lstStyle/>
+                    <a:p>
+                      <a:pPr algn="ctr"/>
+                      <a:r>
+                        <a:rPr sz="1600" b="1">
+                          <a:solidFill>
+                            <a:srgbClr val="2E7D32"/>
+                          </a:solidFill>
+                          <a:latin typeface="Calibri"/>
+                        </a:rPr>
+                        <a:t>✓</a:t>
+                      </a:r>
+                    </a:p>
+                  </a:txBody>
+                  <a:tcPr anchor="ctr" marL="64008" marR="64008" marT="27432" marB="27432">
+                    <a:solidFill>
+                      <a:srgbClr val="D9F2E3"/>
+                    </a:solidFill>
+                  </a:tcPr>
+                </a:tc>
+                <a:tc>
+                  <a:txBody>
+                    <a:bodyPr wrap="square"/>
+                    <a:lstStyle/>
+                    <a:p>
+                      <a:pPr algn="ctr"/>
+                      <a:r>
+                        <a:rPr sz="1600" b="1">
+                          <a:solidFill>
+                            <a:srgbClr val="2E7D32"/>
+                          </a:solidFill>
+                          <a:latin typeface="Calibri"/>
+                        </a:rPr>
+                        <a:t>✓</a:t>
+                      </a:r>
+                    </a:p>
+                  </a:txBody>
+                  <a:tcPr anchor="ctr" marL="64008" marR="64008" marT="27432" marB="27432">
+                    <a:solidFill>
+                      <a:srgbClr val="D9F2E3"/>
+                    </a:solidFill>
+                  </a:tcPr>
+                </a:tc>
+                <a:tc>
+                  <a:txBody>
+                    <a:bodyPr wrap="square"/>
+                    <a:lstStyle/>
+                    <a:p>
+                      <a:pPr algn="ctr"/>
+                      <a:r>
+                        <a:rPr sz="1600" b="1">
+                          <a:solidFill>
+                            <a:srgbClr val="2E7D32"/>
+                          </a:solidFill>
+                          <a:latin typeface="Calibri"/>
+                        </a:rPr>
+                        <a:t>✓</a:t>
+                      </a:r>
+                    </a:p>
+                  </a:txBody>
+                  <a:tcPr anchor="ctr" marL="64008" marR="64008" marT="27432" marB="27432">
+                    <a:solidFill>
+                      <a:srgbClr val="D9F2E3"/>
+                    </a:solidFill>
+                  </a:tcPr>
+                </a:tc>
+                <a:tc>
+                  <a:txBody>
+                    <a:bodyPr wrap="square"/>
+                    <a:lstStyle/>
+                    <a:p>
+                      <a:pPr algn="ctr"/>
+                      <a:r>
+                        <a:rPr sz="1600" b="1">
+                          <a:solidFill>
+                            <a:srgbClr val="2E7D32"/>
+                          </a:solidFill>
+                          <a:latin typeface="Calibri"/>
+                        </a:rPr>
+                        <a:t>✓</a:t>
+                      </a:r>
+                    </a:p>
+                  </a:txBody>
+                  <a:tcPr anchor="ctr" marL="64008" marR="64008" marT="27432" marB="27432">
+                    <a:solidFill>
+                      <a:srgbClr val="D9F2E3"/>
+                    </a:solidFill>
+                  </a:tcPr>
+                </a:tc>
+              </a:tr>
+            </a:tbl>
+          </a:graphicData>
+        </a:graphic>
+      </p:graphicFrame>
+      <p:sp>
+        <p:nvSpPr>
+          <p:cNvPr id="21" name="TextBox 20"/>
+          <p:cNvSpPr txBox="1"/>
+          <p:nvPr/>
+        </p:nvSpPr>
+        <p:spPr>
+          <a:xfrm>
+            <a:off x="12298680" y="5641848"/>
+            <a:ext cx="5394960" cy="274320"/>
+          </a:xfrm>
+          <a:prstGeom prst="rect">
+            <a:avLst/>
+          </a:prstGeom>
+          <a:noFill/>
+        </p:spPr>
+        <p:txBody>
+          <a:bodyPr wrap="square" anchor="t" lIns="45720" rIns="45720" tIns="18288" bIns="18288">
+            <a:spAutoFit/>
+          </a:bodyPr>
+          <a:lstStyle/>
+          <a:p>
+            <a:pPr algn="l"/>
+            <a:r>
+              <a:rPr sz="1100" b="0" i="0">
+                <a:solidFill>
+                  <a:srgbClr val="404040"/>
+                </a:solidFill>
+                <a:latin typeface="Calibri"/>
+              </a:rPr>
+              <a:t>✓ yes    ~ partly    ✗ no</a:t>
+            </a:r>
+          </a:p>
+        </p:txBody>
+      </p:sp>
+      <p:sp>
+        <p:nvSpPr>
+          <p:cNvPr id="22" name="Rounded Rectangle 21"/>
+          <p:cNvSpPr/>
+          <p:nvPr/>
+        </p:nvSpPr>
+        <p:spPr>
+          <a:xfrm>
+            <a:off x="12298680" y="6007608"/>
+            <a:ext cx="5404104" cy="1097280"/>
+          </a:xfrm>
+          <a:prstGeom prst="roundRect">
+            <a:avLst>
+              <a:gd name="adj" fmla="val 12000"/>
+            </a:avLst>
+          </a:prstGeom>
+          <a:solidFill>
+            <a:srgbClr val="E8F5F3"/>
+          </a:solidFill>
+          <a:ln w="15875">
+            <a:solidFill>
+              <a:srgbClr val="0F766E"/>
+            </a:solidFill>
+          </a:ln>
+          <a:effectLst/>
+        </p:spPr>
+        <p:style>
+          <a:lnRef idx="1">
+            <a:schemeClr val="accent1"/>
+          </a:lnRef>
+          <a:fillRef idx="3">
+            <a:schemeClr val="accent1"/>
+          </a:fillRef>
+          <a:effectRef idx="2">
+            <a:schemeClr val="accent1"/>
+          </a:effectRef>
+          <a:fontRef idx="minor">
+            <a:schemeClr val="lt1"/>
+          </a:fontRef>
+        </p:style>
+        <p:txBody>
+          <a:bodyPr rtlCol="0" anchor="ctr" wrap="square" lIns="45720" rIns="45720" tIns="18288" bIns="18288"/>
+          <a:lstStyle/>
+          <a:p>
+            <a:pPr algn="ctr"/>
+            <a:r>
+              <a:rPr sz="1250" b="1">
+                <a:solidFill>
+                  <a:srgbClr val="0F4C46"/>
+                </a:solidFill>
+                <a:latin typeface="Calibri"/>
+              </a:rPr>
+              <a:t>Our edge: not just a colour reader.</a:t>
+            </a:r>
+          </a:p>
+          <a:p>
+            <a:pPr algn="ctr"/>
+            <a:r>
+              <a:rPr sz="1250" b="1">
+                <a:solidFill>
+                  <a:srgbClr val="0F4C46"/>
+                </a:solidFill>
+                <a:latin typeface="Calibri"/>
+              </a:rPr>
+              <a:t>The signed, chained evidence record</a:t>
+            </a:r>
+          </a:p>
+          <a:p>
+            <a:pPr algn="ctr"/>
+            <a:r>
+              <a:rPr sz="1250" b="1">
+                <a:solidFill>
+                  <a:srgbClr val="0F4C46"/>
+                </a:solidFill>
+                <a:latin typeface="Calibri"/>
+              </a:rPr>
+              <a:t>is the product - checkable by anyone.</a:t>
+            </a:r>
+          </a:p>
+        </p:txBody>
+      </p:sp>
     </p:spTree>
   </p:cSld>
   <p:clrMapOvr>

</xml_diff>

<commit_message>
Make every research and source link clickable in the PDF
PowerPoint drops hyperlinks inside table cells and misplaces multiple links
in one text box when exporting to PDF. Added an invisible clickable box over
each research title and split the official sources into separate link boxes;
all 12 links on slide 6 now work in both PPTX and PDF.

Co-Authored-By: Claude Opus 5.5 <noreply@anthropic.com>
</commit_message>
<xml_diff>
--- a/docs/SIH26231_FieldProof_HexTech.pptx
+++ b/docs/SIH26231_FieldProof_HexTech.pptx
@@ -15592,7 +15592,9 @@
       </p:sp>
       <p:sp>
         <p:nvSpPr>
-          <p:cNvPr name="TextBox 16" id="16"/>
+          <p:cNvPr name="TextBox 16" id="16">
+            <a:hlinkClick r:id="rId9"/>
+          </p:cNvPr>
           <p:cNvSpPr txBox="true"/>
           <p:nvPr/>
         </p:nvSpPr>
@@ -16505,106 +16507,322 @@
       </p:graphicFrame>
       <p:sp>
         <p:nvSpPr>
-          <p:cNvPr id="18" name="TextBox 17"/>
-          <p:cNvSpPr txBox="1"/>
-          <p:nvPr/>
-        </p:nvSpPr>
-        <p:spPr>
-          <a:xfrm>
-            <a:off x="822960" y="7708392"/>
-            <a:ext cx="11338560" cy="365760"/>
+          <p:cNvPr id="18" name="Rectangle 17">
+            <a:hlinkClick r:id="rId12"/>
+          </p:cNvPr>
+          <p:cNvSpPr/>
+          <p:nvPr/>
+        </p:nvSpPr>
+        <p:spPr>
+          <a:xfrm>
+            <a:off x="1188720" y="2240280"/>
+            <a:ext cx="4983480" cy="768096"/>
           </a:xfrm>
           <a:prstGeom prst="rect">
             <a:avLst/>
           </a:prstGeom>
           <a:noFill/>
-        </p:spPr>
-        <p:txBody>
-          <a:bodyPr wrap="none">
-            <a:spAutoFit/>
-          </a:bodyPr>
-          <a:lstStyle/>
-          <a:p>
-            <a:r>
-              <a:rPr b="1" sz="1300">
-                <a:solidFill>
-                  <a:srgbClr val="1F3864"/>
-                </a:solidFill>
-                <a:latin typeface="Calibri"/>
-              </a:rPr>
-              <a:t>Official sources:  </a:t>
-            </a:r>
-            <a:r>
-              <a:rPr sz="1300" u="sng">
-                <a:solidFill>
-                  <a:srgbClr val="0563C1"/>
-                </a:solidFill>
-                <a:latin typeface="Calibri"/>
-                <a:hlinkClick r:id="rId19"/>
-              </a:rPr>
-              <a:t>NDPS Act &amp; Sampling Rules 2022</a:t>
-            </a:r>
-            <a:r>
-              <a:rPr sz="1300">
-                <a:latin typeface="Calibri"/>
-              </a:rPr>
-              <a:t>   ·   </a:t>
-            </a:r>
-            <a:r>
-              <a:rPr sz="1300" u="sng">
-                <a:solidFill>
-                  <a:srgbClr val="0563C1"/>
-                </a:solidFill>
-                <a:latin typeface="Calibri"/>
-                <a:hlinkClick r:id="rId20"/>
-              </a:rPr>
-              <a:t>NCB Field Officers' Handbook</a:t>
-            </a:r>
-            <a:r>
-              <a:rPr sz="1300">
-                <a:latin typeface="Calibri"/>
-              </a:rPr>
-              <a:t>   ·   </a:t>
-            </a:r>
-            <a:r>
-              <a:rPr sz="1300" u="sng">
-                <a:solidFill>
-                  <a:srgbClr val="0563C1"/>
-                </a:solidFill>
-                <a:latin typeface="Calibri"/>
-                <a:hlinkClick r:id="rId21"/>
-              </a:rPr>
-              <a:t>UNODC Drug Field-Testing Manual</a:t>
-            </a:r>
-            <a:r>
-              <a:rPr sz="1300">
-                <a:latin typeface="Calibri"/>
-              </a:rPr>
-              <a:t>   ·   </a:t>
-            </a:r>
-            <a:r>
-              <a:rPr sz="1300" u="sng">
-                <a:solidFill>
-                  <a:srgbClr val="0563C1"/>
-                </a:solidFill>
-                <a:latin typeface="Calibri"/>
-                <a:hlinkClick r:id="rId22"/>
-              </a:rPr>
-              <a:t>BNSS / BSA 2023 (MHA)</a:t>
-            </a:r>
-          </a:p>
-        </p:txBody>
-      </p:sp>
-      <p:sp>
-        <p:nvSpPr>
-          <p:cNvPr id="19" name="TextBox 18"/>
+          <a:ln>
+            <a:noFill/>
+          </a:ln>
+          <a:effectLst/>
+        </p:spPr>
+        <p:style>
+          <a:lnRef idx="1">
+            <a:schemeClr val="accent1"/>
+          </a:lnRef>
+          <a:fillRef idx="3">
+            <a:schemeClr val="accent1"/>
+          </a:fillRef>
+          <a:effectRef idx="2">
+            <a:schemeClr val="accent1"/>
+          </a:effectRef>
+          <a:fontRef idx="minor">
+            <a:schemeClr val="lt1"/>
+          </a:fontRef>
+        </p:style>
+        <p:txBody>
+          <a:bodyPr rtlCol="0" anchor="ctr"/>
+          <a:lstStyle/>
+          <a:p>
+            <a:pPr algn="ctr"/>
+          </a:p>
+        </p:txBody>
+      </p:sp>
+      <p:sp>
+        <p:nvSpPr>
+          <p:cNvPr id="19" name="Rectangle 18">
+            <a:hlinkClick r:id="rId13"/>
+          </p:cNvPr>
+          <p:cNvSpPr/>
+          <p:nvPr/>
+        </p:nvSpPr>
+        <p:spPr>
+          <a:xfrm>
+            <a:off x="1188720" y="3008376"/>
+            <a:ext cx="4983480" cy="768096"/>
+          </a:xfrm>
+          <a:prstGeom prst="rect">
+            <a:avLst/>
+          </a:prstGeom>
+          <a:noFill/>
+          <a:ln>
+            <a:noFill/>
+          </a:ln>
+          <a:effectLst/>
+        </p:spPr>
+        <p:style>
+          <a:lnRef idx="1">
+            <a:schemeClr val="accent1"/>
+          </a:lnRef>
+          <a:fillRef idx="3">
+            <a:schemeClr val="accent1"/>
+          </a:fillRef>
+          <a:effectRef idx="2">
+            <a:schemeClr val="accent1"/>
+          </a:effectRef>
+          <a:fontRef idx="minor">
+            <a:schemeClr val="lt1"/>
+          </a:fontRef>
+        </p:style>
+        <p:txBody>
+          <a:bodyPr rtlCol="0" anchor="ctr"/>
+          <a:lstStyle/>
+          <a:p>
+            <a:pPr algn="ctr"/>
+          </a:p>
+        </p:txBody>
+      </p:sp>
+      <p:sp>
+        <p:nvSpPr>
+          <p:cNvPr id="20" name="Rectangle 19">
+            <a:hlinkClick r:id="rId14"/>
+          </p:cNvPr>
+          <p:cNvSpPr/>
+          <p:nvPr/>
+        </p:nvSpPr>
+        <p:spPr>
+          <a:xfrm>
+            <a:off x="1188720" y="3776472"/>
+            <a:ext cx="4983480" cy="768096"/>
+          </a:xfrm>
+          <a:prstGeom prst="rect">
+            <a:avLst/>
+          </a:prstGeom>
+          <a:noFill/>
+          <a:ln>
+            <a:noFill/>
+          </a:ln>
+          <a:effectLst/>
+        </p:spPr>
+        <p:style>
+          <a:lnRef idx="1">
+            <a:schemeClr val="accent1"/>
+          </a:lnRef>
+          <a:fillRef idx="3">
+            <a:schemeClr val="accent1"/>
+          </a:fillRef>
+          <a:effectRef idx="2">
+            <a:schemeClr val="accent1"/>
+          </a:effectRef>
+          <a:fontRef idx="minor">
+            <a:schemeClr val="lt1"/>
+          </a:fontRef>
+        </p:style>
+        <p:txBody>
+          <a:bodyPr rtlCol="0" anchor="ctr"/>
+          <a:lstStyle/>
+          <a:p>
+            <a:pPr algn="ctr"/>
+          </a:p>
+        </p:txBody>
+      </p:sp>
+      <p:sp>
+        <p:nvSpPr>
+          <p:cNvPr id="21" name="Rectangle 20">
+            <a:hlinkClick r:id="rId15"/>
+          </p:cNvPr>
+          <p:cNvSpPr/>
+          <p:nvPr/>
+        </p:nvSpPr>
+        <p:spPr>
+          <a:xfrm>
+            <a:off x="1188720" y="4544568"/>
+            <a:ext cx="4983480" cy="768096"/>
+          </a:xfrm>
+          <a:prstGeom prst="rect">
+            <a:avLst/>
+          </a:prstGeom>
+          <a:noFill/>
+          <a:ln>
+            <a:noFill/>
+          </a:ln>
+          <a:effectLst/>
+        </p:spPr>
+        <p:style>
+          <a:lnRef idx="1">
+            <a:schemeClr val="accent1"/>
+          </a:lnRef>
+          <a:fillRef idx="3">
+            <a:schemeClr val="accent1"/>
+          </a:fillRef>
+          <a:effectRef idx="2">
+            <a:schemeClr val="accent1"/>
+          </a:effectRef>
+          <a:fontRef idx="minor">
+            <a:schemeClr val="lt1"/>
+          </a:fontRef>
+        </p:style>
+        <p:txBody>
+          <a:bodyPr rtlCol="0" anchor="ctr"/>
+          <a:lstStyle/>
+          <a:p>
+            <a:pPr algn="ctr"/>
+          </a:p>
+        </p:txBody>
+      </p:sp>
+      <p:sp>
+        <p:nvSpPr>
+          <p:cNvPr id="22" name="Rectangle 21">
+            <a:hlinkClick r:id="rId16"/>
+          </p:cNvPr>
+          <p:cNvSpPr/>
+          <p:nvPr/>
+        </p:nvSpPr>
+        <p:spPr>
+          <a:xfrm>
+            <a:off x="1188720" y="5312664"/>
+            <a:ext cx="4983480" cy="768096"/>
+          </a:xfrm>
+          <a:prstGeom prst="rect">
+            <a:avLst/>
+          </a:prstGeom>
+          <a:noFill/>
+          <a:ln>
+            <a:noFill/>
+          </a:ln>
+          <a:effectLst/>
+        </p:spPr>
+        <p:style>
+          <a:lnRef idx="1">
+            <a:schemeClr val="accent1"/>
+          </a:lnRef>
+          <a:fillRef idx="3">
+            <a:schemeClr val="accent1"/>
+          </a:fillRef>
+          <a:effectRef idx="2">
+            <a:schemeClr val="accent1"/>
+          </a:effectRef>
+          <a:fontRef idx="minor">
+            <a:schemeClr val="lt1"/>
+          </a:fontRef>
+        </p:style>
+        <p:txBody>
+          <a:bodyPr rtlCol="0" anchor="ctr"/>
+          <a:lstStyle/>
+          <a:p>
+            <a:pPr algn="ctr"/>
+          </a:p>
+        </p:txBody>
+      </p:sp>
+      <p:sp>
+        <p:nvSpPr>
+          <p:cNvPr id="23" name="Rectangle 22">
+            <a:hlinkClick r:id="rId17"/>
+          </p:cNvPr>
+          <p:cNvSpPr/>
+          <p:nvPr/>
+        </p:nvSpPr>
+        <p:spPr>
+          <a:xfrm>
+            <a:off x="1188720" y="6080760"/>
+            <a:ext cx="4983480" cy="768096"/>
+          </a:xfrm>
+          <a:prstGeom prst="rect">
+            <a:avLst/>
+          </a:prstGeom>
+          <a:noFill/>
+          <a:ln>
+            <a:noFill/>
+          </a:ln>
+          <a:effectLst/>
+        </p:spPr>
+        <p:style>
+          <a:lnRef idx="1">
+            <a:schemeClr val="accent1"/>
+          </a:lnRef>
+          <a:fillRef idx="3">
+            <a:schemeClr val="accent1"/>
+          </a:fillRef>
+          <a:effectRef idx="2">
+            <a:schemeClr val="accent1"/>
+          </a:effectRef>
+          <a:fontRef idx="minor">
+            <a:schemeClr val="lt1"/>
+          </a:fontRef>
+        </p:style>
+        <p:txBody>
+          <a:bodyPr rtlCol="0" anchor="ctr"/>
+          <a:lstStyle/>
+          <a:p>
+            <a:pPr algn="ctr"/>
+          </a:p>
+        </p:txBody>
+      </p:sp>
+      <p:sp>
+        <p:nvSpPr>
+          <p:cNvPr id="24" name="Rectangle 23">
+            <a:hlinkClick r:id="rId18"/>
+          </p:cNvPr>
+          <p:cNvSpPr/>
+          <p:nvPr/>
+        </p:nvSpPr>
+        <p:spPr>
+          <a:xfrm>
+            <a:off x="1188720" y="6848856"/>
+            <a:ext cx="4983480" cy="768096"/>
+          </a:xfrm>
+          <a:prstGeom prst="rect">
+            <a:avLst/>
+          </a:prstGeom>
+          <a:noFill/>
+          <a:ln>
+            <a:noFill/>
+          </a:ln>
+          <a:effectLst/>
+        </p:spPr>
+        <p:style>
+          <a:lnRef idx="1">
+            <a:schemeClr val="accent1"/>
+          </a:lnRef>
+          <a:fillRef idx="3">
+            <a:schemeClr val="accent1"/>
+          </a:fillRef>
+          <a:effectRef idx="2">
+            <a:schemeClr val="accent1"/>
+          </a:effectRef>
+          <a:fontRef idx="minor">
+            <a:schemeClr val="lt1"/>
+          </a:fontRef>
+        </p:style>
+        <p:txBody>
+          <a:bodyPr rtlCol="0" anchor="ctr"/>
+          <a:lstStyle/>
+          <a:p>
+            <a:pPr algn="ctr"/>
+          </a:p>
+        </p:txBody>
+      </p:sp>
+      <p:sp>
+        <p:nvSpPr>
+          <p:cNvPr id="25" name="TextBox 24"/>
           <p:cNvSpPr txBox="1"/>
           <p:nvPr/>
         </p:nvSpPr>
         <p:spPr>
           <a:xfrm>
-            <a:off x="12298680" y="1737360"/>
-            <a:ext cx="5486400" cy="411480"/>
+            <a:off x="822960" y="7708392"/>
+            <a:ext cx="1554480" cy="365760"/>
           </a:xfrm>
           <a:prstGeom prst="rect">
             <a:avLst/>
@@ -16619,6 +16837,189 @@
           <a:p>
             <a:pPr algn="l"/>
             <a:r>
+              <a:rPr sz="1300" b="1" i="0">
+                <a:solidFill>
+                  <a:srgbClr val="1F3864"/>
+                </a:solidFill>
+                <a:latin typeface="Calibri"/>
+              </a:rPr>
+              <a:t>Official sources:</a:t>
+            </a:r>
+          </a:p>
+        </p:txBody>
+      </p:sp>
+      <p:sp>
+        <p:nvSpPr>
+          <p:cNvPr id="26" name="TextBox 25">
+            <a:hlinkClick r:id="rId19"/>
+          </p:cNvPr>
+          <p:cNvSpPr txBox="1"/>
+          <p:nvPr/>
+        </p:nvSpPr>
+        <p:spPr>
+          <a:xfrm>
+            <a:off x="2331720" y="7708392"/>
+            <a:ext cx="2459736" cy="365760"/>
+          </a:xfrm>
+          <a:prstGeom prst="rect">
+            <a:avLst/>
+          </a:prstGeom>
+          <a:noFill/>
+        </p:spPr>
+        <p:txBody>
+          <a:bodyPr wrap="none" lIns="18288" rIns="18288">
+            <a:spAutoFit/>
+          </a:bodyPr>
+          <a:lstStyle/>
+          <a:p>
+            <a:r>
+              <a:rPr sz="1300" u="sng">
+                <a:solidFill>
+                  <a:srgbClr val="0563C1"/>
+                </a:solidFill>
+                <a:latin typeface="Calibri"/>
+                <a:hlinkClick r:id="rId19"/>
+              </a:rPr>
+              <a:t>NDPS Act &amp; Sampling Rules 2022</a:t>
+            </a:r>
+          </a:p>
+        </p:txBody>
+      </p:sp>
+      <p:sp>
+        <p:nvSpPr>
+          <p:cNvPr id="27" name="TextBox 26">
+            <a:hlinkClick r:id="rId20"/>
+          </p:cNvPr>
+          <p:cNvSpPr txBox="1"/>
+          <p:nvPr/>
+        </p:nvSpPr>
+        <p:spPr>
+          <a:xfrm>
+            <a:off x="5020056" y="7708392"/>
+            <a:ext cx="2307945" cy="365760"/>
+          </a:xfrm>
+          <a:prstGeom prst="rect">
+            <a:avLst/>
+          </a:prstGeom>
+          <a:noFill/>
+        </p:spPr>
+        <p:txBody>
+          <a:bodyPr wrap="none" lIns="18288" rIns="18288">
+            <a:spAutoFit/>
+          </a:bodyPr>
+          <a:lstStyle/>
+          <a:p>
+            <a:r>
+              <a:rPr sz="1300" u="sng">
+                <a:solidFill>
+                  <a:srgbClr val="0563C1"/>
+                </a:solidFill>
+                <a:latin typeface="Calibri"/>
+                <a:hlinkClick r:id="rId20"/>
+              </a:rPr>
+              <a:t>NCB Field Officers' Handbook</a:t>
+            </a:r>
+          </a:p>
+        </p:txBody>
+      </p:sp>
+      <p:sp>
+        <p:nvSpPr>
+          <p:cNvPr id="28" name="TextBox 27">
+            <a:hlinkClick r:id="rId21"/>
+          </p:cNvPr>
+          <p:cNvSpPr txBox="1"/>
+          <p:nvPr/>
+        </p:nvSpPr>
+        <p:spPr>
+          <a:xfrm>
+            <a:off x="7556601" y="7708392"/>
+            <a:ext cx="2535631" cy="365760"/>
+          </a:xfrm>
+          <a:prstGeom prst="rect">
+            <a:avLst/>
+          </a:prstGeom>
+          <a:noFill/>
+        </p:spPr>
+        <p:txBody>
+          <a:bodyPr wrap="none" lIns="18288" rIns="18288">
+            <a:spAutoFit/>
+          </a:bodyPr>
+          <a:lstStyle/>
+          <a:p>
+            <a:r>
+              <a:rPr sz="1300" u="sng">
+                <a:solidFill>
+                  <a:srgbClr val="0563C1"/>
+                </a:solidFill>
+                <a:latin typeface="Calibri"/>
+                <a:hlinkClick r:id="rId21"/>
+              </a:rPr>
+              <a:t>UNODC Drug Field-Testing Manual</a:t>
+            </a:r>
+          </a:p>
+        </p:txBody>
+      </p:sp>
+      <p:sp>
+        <p:nvSpPr>
+          <p:cNvPr id="29" name="TextBox 28">
+            <a:hlinkClick r:id="rId22"/>
+          </p:cNvPr>
+          <p:cNvSpPr txBox="1"/>
+          <p:nvPr/>
+        </p:nvSpPr>
+        <p:spPr>
+          <a:xfrm>
+            <a:off x="10320832" y="7708392"/>
+            <a:ext cx="1776679" cy="365760"/>
+          </a:xfrm>
+          <a:prstGeom prst="rect">
+            <a:avLst/>
+          </a:prstGeom>
+          <a:noFill/>
+        </p:spPr>
+        <p:txBody>
+          <a:bodyPr wrap="none" lIns="18288" rIns="18288">
+            <a:spAutoFit/>
+          </a:bodyPr>
+          <a:lstStyle/>
+          <a:p>
+            <a:r>
+              <a:rPr sz="1300" u="sng">
+                <a:solidFill>
+                  <a:srgbClr val="0563C1"/>
+                </a:solidFill>
+                <a:latin typeface="Calibri"/>
+                <a:hlinkClick r:id="rId22"/>
+              </a:rPr>
+              <a:t>BNSS / BSA 2023 (MHA)</a:t>
+            </a:r>
+          </a:p>
+        </p:txBody>
+      </p:sp>
+      <p:sp>
+        <p:nvSpPr>
+          <p:cNvPr id="30" name="TextBox 29"/>
+          <p:cNvSpPr txBox="1"/>
+          <p:nvPr/>
+        </p:nvSpPr>
+        <p:spPr>
+          <a:xfrm>
+            <a:off x="12298680" y="1737360"/>
+            <a:ext cx="5486400" cy="411480"/>
+          </a:xfrm>
+          <a:prstGeom prst="rect">
+            <a:avLst/>
+          </a:prstGeom>
+          <a:noFill/>
+        </p:spPr>
+        <p:txBody>
+          <a:bodyPr wrap="square" anchor="t" lIns="45720" rIns="45720" tIns="18288" bIns="18288">
+            <a:spAutoFit/>
+          </a:bodyPr>
+          <a:lstStyle/>
+          <a:p>
+            <a:pPr algn="l"/>
+            <a:r>
               <a:rPr sz="1800" b="1" i="0">
                 <a:solidFill>
                   <a:srgbClr val="1F3864"/>
@@ -16632,7 +17033,7 @@
       </p:sp>
       <p:graphicFrame>
         <p:nvGraphicFramePr>
-          <p:cNvPr id="20" name="Table 19"/>
+          <p:cNvPr id="31" name="Table 30"/>
           <p:cNvGraphicFramePr>
             <a:graphicFrameLocks noGrp="1"/>
           </p:cNvGraphicFramePr>
@@ -17480,7 +17881,7 @@
       </p:graphicFrame>
       <p:sp>
         <p:nvSpPr>
-          <p:cNvPr id="21" name="TextBox 20"/>
+          <p:cNvPr id="32" name="TextBox 31"/>
           <p:cNvSpPr txBox="1"/>
           <p:nvPr/>
         </p:nvSpPr>
@@ -17515,7 +17916,7 @@
       </p:sp>
       <p:sp>
         <p:nvSpPr>
-          <p:cNvPr id="22" name="Rounded Rectangle 21"/>
+          <p:cNvPr id="33" name="Rounded Rectangle 32"/>
           <p:cNvSpPr/>
           <p:nvPr/>
         </p:nvSpPr>

</xml_diff>